<commit_message>
Rediseño del workflow de generación de PPT (v5)
- planificar_slides.py (nuevo): capa de planificación pedagógica que decide
  cuántos slides genera la ICN, qué composición usa cada uno (icn_flexible,
  anatomia, analogia, demos) y dónde intercalar los demos según su posición
  en el spec (no al final).
- crear_ppt.py: refactorizado con construir_slide_icn_flexible() y
  construir_slide_haz_ahora_flex() que componen bloques dinámicamente;
  PPT ahora termina en errores típicos (sin guiada/independiente/ticket/cierre);
  flags --preview-icn y --preview-hazahora para validación por sección.
- SKILL.md de generar-ppt-clase: reescrito para reflejar la nueva arquitectura.
- CLAUDE.md: restricción permanente — el PPT termina en errores típicos.
- clase-08a-booleano-test: spec aprobada + PPT generado como caso de prueba.

Co-Authored-By: Claude Sonnet 4.6 <noreply@anthropic.com>
</commit_message>
<xml_diff>
--- a/.claude/skills/generar-ppt-clase/plantilla_marca.pptx
+++ b/.claude/skills/generar-ppt-clase/plantilla_marca.pptx
@@ -15,6 +15,10 @@
     <p:sldId id="263" r:id="rId14"/>
     <p:sldId id="264" r:id="rId15"/>
     <p:sldId id="265" r:id="rId16"/>
+    <p:sldId id="266" r:id="rId17"/>
+    <p:sldId id="267" r:id="rId18"/>
+    <p:sldId id="268" r:id="rId19"/>
+    <p:sldId id="269" r:id="rId20"/>
   </p:sldIdLst>
   <p:sldSz cx="12191695" cy="6858000" type="screen4x3"/>
   <p:notesSz cx="6858000" cy="9144000"/>
@@ -4568,6 +4572,3641 @@
                 <a:latin typeface="Consolas"/>
               </a:rPr>
               <a:t>{{FILA_3_RESULTADO}}</a:t>
+            </a:r>
+          </a:p>
+        </p:txBody>
+      </p:sp>
+    </p:spTree>
+  </p:cSld>
+  <p:clrMapOvr>
+    <a:masterClrMapping/>
+  </p:clrMapOvr>
+</p:sld>
+</file>
+
+<file path=ppt/slides/slide11.xml><?xml version="1.0" encoding="utf-8"?>
+<p:sld xmlns:a="http://schemas.openxmlformats.org/drawingml/2006/main" xmlns:p="http://schemas.openxmlformats.org/presentationml/2006/main" xmlns:r="http://schemas.openxmlformats.org/officeDocument/2006/relationships">
+  <p:cSld>
+    <p:spTree>
+      <p:nvGrpSpPr>
+        <p:cNvPr id="1" name=""/>
+        <p:cNvGrpSpPr/>
+        <p:nvPr/>
+      </p:nvGrpSpPr>
+      <p:grpSpPr/>
+      <p:sp>
+        <p:nvSpPr>
+          <p:cNvPr id="2" name="Rectangle 1"/>
+          <p:cNvSpPr/>
+          <p:nvPr/>
+        </p:nvSpPr>
+        <p:spPr>
+          <a:xfrm>
+            <a:off x="0" y="0"/>
+            <a:ext cx="12191695" cy="6858000"/>
+          </a:xfrm>
+          <a:prstGeom prst="rect">
+            <a:avLst/>
+          </a:prstGeom>
+          <a:solidFill>
+            <a:srgbClr val="1A1A2E"/>
+          </a:solidFill>
+          <a:ln>
+            <a:noFill/>
+          </a:ln>
+          <a:effectLst/>
+        </p:spPr>
+        <p:style>
+          <a:lnRef idx="1">
+            <a:schemeClr val="accent1"/>
+          </a:lnRef>
+          <a:fillRef idx="3">
+            <a:schemeClr val="accent1"/>
+          </a:fillRef>
+          <a:effectRef idx="2">
+            <a:schemeClr val="accent1"/>
+          </a:effectRef>
+          <a:fontRef idx="minor">
+            <a:schemeClr val="lt1"/>
+          </a:fontRef>
+        </p:style>
+        <p:txBody>
+          <a:bodyPr rtlCol="0" anchor="ctr"/>
+          <a:lstStyle/>
+          <a:p>
+            <a:pPr algn="ctr"/>
+          </a:p>
+        </p:txBody>
+      </p:sp>
+      <p:sp>
+        <p:nvSpPr>
+          <p:cNvPr id="3" name="Rectangle 2"/>
+          <p:cNvSpPr/>
+          <p:nvPr/>
+        </p:nvSpPr>
+        <p:spPr>
+          <a:xfrm>
+            <a:off x="0" y="0"/>
+            <a:ext cx="12191695" cy="502920"/>
+          </a:xfrm>
+          <a:prstGeom prst="rect">
+            <a:avLst/>
+          </a:prstGeom>
+          <a:solidFill>
+            <a:srgbClr val="0F162A"/>
+          </a:solidFill>
+          <a:ln>
+            <a:noFill/>
+          </a:ln>
+          <a:effectLst/>
+        </p:spPr>
+        <p:style>
+          <a:lnRef idx="1">
+            <a:schemeClr val="accent1"/>
+          </a:lnRef>
+          <a:fillRef idx="3">
+            <a:schemeClr val="accent1"/>
+          </a:fillRef>
+          <a:effectRef idx="2">
+            <a:schemeClr val="accent1"/>
+          </a:effectRef>
+          <a:fontRef idx="minor">
+            <a:schemeClr val="lt1"/>
+          </a:fontRef>
+        </p:style>
+        <p:txBody>
+          <a:bodyPr rtlCol="0" anchor="ctr"/>
+          <a:lstStyle/>
+          <a:p>
+            <a:pPr algn="ctr"/>
+          </a:p>
+        </p:txBody>
+      </p:sp>
+      <p:sp>
+        <p:nvSpPr>
+          <p:cNvPr id="4" name="TextBox 3"/>
+          <p:cNvSpPr txBox="1"/>
+          <p:nvPr/>
+        </p:nvSpPr>
+        <p:spPr>
+          <a:xfrm>
+            <a:off x="411479" y="118872"/>
+            <a:ext cx="5486400" cy="320040"/>
+          </a:xfrm>
+          <a:prstGeom prst="rect">
+            <a:avLst/>
+          </a:prstGeom>
+          <a:noFill/>
+        </p:spPr>
+        <p:txBody>
+          <a:bodyPr wrap="square" anchor="ctr">
+            <a:spAutoFit/>
+          </a:bodyPr>
+          <a:lstStyle/>
+          <a:p>
+            <a:pPr algn="l"/>
+            <a:r>
+              <a:rPr sz="1200" b="0">
+                <a:solidFill>
+                  <a:srgbClr val="94A3B8"/>
+                </a:solidFill>
+                <a:latin typeface="Consolas"/>
+              </a:rPr>
+              <a:t>🐍 Python · Clase {{NUMERO_CLASE}}</a:t>
+            </a:r>
+          </a:p>
+        </p:txBody>
+      </p:sp>
+      <p:sp>
+        <p:nvSpPr>
+          <p:cNvPr id="5" name="TextBox 4"/>
+          <p:cNvSpPr txBox="1"/>
+          <p:nvPr/>
+        </p:nvSpPr>
+        <p:spPr>
+          <a:xfrm>
+            <a:off x="8534095" y="118872"/>
+            <a:ext cx="3200400" cy="320040"/>
+          </a:xfrm>
+          <a:prstGeom prst="rect">
+            <a:avLst/>
+          </a:prstGeom>
+          <a:noFill/>
+        </p:spPr>
+        <p:txBody>
+          <a:bodyPr wrap="square" anchor="ctr">
+            <a:spAutoFit/>
+          </a:bodyPr>
+          <a:lstStyle/>
+          <a:p>
+            <a:pPr algn="r"/>
+            <a:r>
+              <a:rPr sz="1200" b="1">
+                <a:solidFill>
+                  <a:srgbClr val="0F9B8E"/>
+                </a:solidFill>
+                <a:latin typeface="Consolas"/>
+              </a:rPr>
+              <a:t>{{SECCION}}</a:t>
+            </a:r>
+          </a:p>
+        </p:txBody>
+      </p:sp>
+      <p:sp>
+        <p:nvSpPr>
+          <p:cNvPr id="6" name="TextBox 5"/>
+          <p:cNvSpPr txBox="1"/>
+          <p:nvPr/>
+        </p:nvSpPr>
+        <p:spPr>
+          <a:xfrm>
+            <a:off x="548640" y="868680"/>
+            <a:ext cx="11094415" cy="685800"/>
+          </a:xfrm>
+          <a:prstGeom prst="rect">
+            <a:avLst/>
+          </a:prstGeom>
+          <a:noFill/>
+        </p:spPr>
+        <p:txBody>
+          <a:bodyPr wrap="square" anchor="t">
+            <a:spAutoFit/>
+          </a:bodyPr>
+          <a:lstStyle/>
+          <a:p>
+            <a:pPr algn="l"/>
+            <a:r>
+              <a:rPr sz="3200" b="1">
+                <a:solidFill>
+                  <a:srgbClr val="FFFFFF"/>
+                </a:solidFill>
+                <a:latin typeface="Calibri"/>
+              </a:rPr>
+              <a:t>{{TITULO_SLIDE}}</a:t>
+            </a:r>
+          </a:p>
+        </p:txBody>
+      </p:sp>
+      <p:sp>
+        <p:nvSpPr>
+          <p:cNvPr id="7" name="Rectangle 6"/>
+          <p:cNvSpPr/>
+          <p:nvPr/>
+        </p:nvSpPr>
+        <p:spPr>
+          <a:xfrm>
+            <a:off x="548640" y="1554480"/>
+            <a:ext cx="11094415" cy="868680"/>
+          </a:xfrm>
+          <a:prstGeom prst="rect">
+            <a:avLst/>
+          </a:prstGeom>
+          <a:solidFill>
+            <a:srgbClr val="0D1117"/>
+          </a:solidFill>
+          <a:ln>
+            <a:noFill/>
+          </a:ln>
+          <a:effectLst/>
+        </p:spPr>
+        <p:style>
+          <a:lnRef idx="1">
+            <a:schemeClr val="accent1"/>
+          </a:lnRef>
+          <a:fillRef idx="3">
+            <a:schemeClr val="accent1"/>
+          </a:fillRef>
+          <a:effectRef idx="2">
+            <a:schemeClr val="accent1"/>
+          </a:effectRef>
+          <a:fontRef idx="minor">
+            <a:schemeClr val="lt1"/>
+          </a:fontRef>
+        </p:style>
+        <p:txBody>
+          <a:bodyPr rtlCol="0" anchor="ctr"/>
+          <a:lstStyle/>
+          <a:p>
+            <a:pPr algn="ctr"/>
+          </a:p>
+        </p:txBody>
+      </p:sp>
+      <p:sp>
+        <p:nvSpPr>
+          <p:cNvPr id="8" name="Rectangle 7"/>
+          <p:cNvSpPr/>
+          <p:nvPr/>
+        </p:nvSpPr>
+        <p:spPr>
+          <a:xfrm>
+            <a:off x="548640" y="1554480"/>
+            <a:ext cx="11094415" cy="73152"/>
+          </a:xfrm>
+          <a:prstGeom prst="rect">
+            <a:avLst/>
+          </a:prstGeom>
+          <a:solidFill>
+            <a:srgbClr val="0F9B8E"/>
+          </a:solidFill>
+          <a:ln>
+            <a:noFill/>
+          </a:ln>
+          <a:effectLst/>
+        </p:spPr>
+        <p:style>
+          <a:lnRef idx="1">
+            <a:schemeClr val="accent1"/>
+          </a:lnRef>
+          <a:fillRef idx="3">
+            <a:schemeClr val="accent1"/>
+          </a:fillRef>
+          <a:effectRef idx="2">
+            <a:schemeClr val="accent1"/>
+          </a:effectRef>
+          <a:fontRef idx="minor">
+            <a:schemeClr val="lt1"/>
+          </a:fontRef>
+        </p:style>
+        <p:txBody>
+          <a:bodyPr rtlCol="0" anchor="ctr"/>
+          <a:lstStyle/>
+          <a:p>
+            <a:pPr algn="ctr"/>
+          </a:p>
+        </p:txBody>
+      </p:sp>
+      <p:sp>
+        <p:nvSpPr>
+          <p:cNvPr id="9" name="TextBox 8"/>
+          <p:cNvSpPr txBox="1"/>
+          <p:nvPr/>
+        </p:nvSpPr>
+        <p:spPr>
+          <a:xfrm>
+            <a:off x="777240" y="1719072"/>
+            <a:ext cx="10637215" cy="594359"/>
+          </a:xfrm>
+          <a:prstGeom prst="rect">
+            <a:avLst/>
+          </a:prstGeom>
+          <a:noFill/>
+        </p:spPr>
+        <p:txBody>
+          <a:bodyPr wrap="square" anchor="ctr">
+            <a:spAutoFit/>
+          </a:bodyPr>
+          <a:lstStyle/>
+          <a:p>
+            <a:pPr algn="l"/>
+            <a:r>
+              <a:rPr sz="2600" b="0">
+                <a:solidFill>
+                  <a:srgbClr val="4ADFCB"/>
+                </a:solidFill>
+                <a:latin typeface="Consolas"/>
+              </a:rPr>
+              <a:t>{{EXPRESION}}</a:t>
+            </a:r>
+          </a:p>
+        </p:txBody>
+      </p:sp>
+      <p:sp>
+        <p:nvSpPr>
+          <p:cNvPr id="10" name="Rectangle 9"/>
+          <p:cNvSpPr/>
+          <p:nvPr/>
+        </p:nvSpPr>
+        <p:spPr>
+          <a:xfrm>
+            <a:off x="548640" y="2651760"/>
+            <a:ext cx="5410047" cy="1280160"/>
+          </a:xfrm>
+          <a:prstGeom prst="rect">
+            <a:avLst/>
+          </a:prstGeom>
+          <a:solidFill>
+            <a:srgbClr val="16213E"/>
+          </a:solidFill>
+          <a:ln>
+            <a:noFill/>
+          </a:ln>
+          <a:effectLst/>
+        </p:spPr>
+        <p:style>
+          <a:lnRef idx="1">
+            <a:schemeClr val="accent1"/>
+          </a:lnRef>
+          <a:fillRef idx="3">
+            <a:schemeClr val="accent1"/>
+          </a:fillRef>
+          <a:effectRef idx="2">
+            <a:schemeClr val="accent1"/>
+          </a:effectRef>
+          <a:fontRef idx="minor">
+            <a:schemeClr val="lt1"/>
+          </a:fontRef>
+        </p:style>
+        <p:txBody>
+          <a:bodyPr rtlCol="0" anchor="ctr"/>
+          <a:lstStyle/>
+          <a:p>
+            <a:pPr algn="ctr"/>
+          </a:p>
+        </p:txBody>
+      </p:sp>
+      <p:sp>
+        <p:nvSpPr>
+          <p:cNvPr id="11" name="Rectangle 10"/>
+          <p:cNvSpPr/>
+          <p:nvPr/>
+        </p:nvSpPr>
+        <p:spPr>
+          <a:xfrm>
+            <a:off x="548640" y="2651760"/>
+            <a:ext cx="73152" cy="1280160"/>
+          </a:xfrm>
+          <a:prstGeom prst="rect">
+            <a:avLst/>
+          </a:prstGeom>
+          <a:solidFill>
+            <a:srgbClr val="0F9B8E"/>
+          </a:solidFill>
+          <a:ln>
+            <a:noFill/>
+          </a:ln>
+          <a:effectLst/>
+        </p:spPr>
+        <p:style>
+          <a:lnRef idx="1">
+            <a:schemeClr val="accent1"/>
+          </a:lnRef>
+          <a:fillRef idx="3">
+            <a:schemeClr val="accent1"/>
+          </a:fillRef>
+          <a:effectRef idx="2">
+            <a:schemeClr val="accent1"/>
+          </a:effectRef>
+          <a:fontRef idx="minor">
+            <a:schemeClr val="lt1"/>
+          </a:fontRef>
+        </p:style>
+        <p:txBody>
+          <a:bodyPr rtlCol="0" anchor="ctr"/>
+          <a:lstStyle/>
+          <a:p>
+            <a:pPr algn="ctr"/>
+          </a:p>
+        </p:txBody>
+      </p:sp>
+      <p:sp>
+        <p:nvSpPr>
+          <p:cNvPr id="12" name="TextBox 11"/>
+          <p:cNvSpPr txBox="1"/>
+          <p:nvPr/>
+        </p:nvSpPr>
+        <p:spPr>
+          <a:xfrm>
+            <a:off x="731520" y="2724912"/>
+            <a:ext cx="5135727" cy="274320"/>
+          </a:xfrm>
+          <a:prstGeom prst="rect">
+            <a:avLst/>
+          </a:prstGeom>
+          <a:noFill/>
+        </p:spPr>
+        <p:txBody>
+          <a:bodyPr wrap="square" anchor="t">
+            <a:spAutoFit/>
+          </a:bodyPr>
+          <a:lstStyle/>
+          <a:p>
+            <a:pPr algn="l"/>
+            <a:r>
+              <a:rPr sz="1200" b="1">
+                <a:solidFill>
+                  <a:srgbClr val="F5A623"/>
+                </a:solidFill>
+                <a:latin typeface="Calibri"/>
+              </a:rPr>
+              <a:t>{{PARTE_1_LABEL}}</a:t>
+            </a:r>
+          </a:p>
+        </p:txBody>
+      </p:sp>
+      <p:sp>
+        <p:nvSpPr>
+          <p:cNvPr id="13" name="TextBox 12"/>
+          <p:cNvSpPr txBox="1"/>
+          <p:nvPr/>
+        </p:nvSpPr>
+        <p:spPr>
+          <a:xfrm>
+            <a:off x="731520" y="2999232"/>
+            <a:ext cx="5135727" cy="365760"/>
+          </a:xfrm>
+          <a:prstGeom prst="rect">
+            <a:avLst/>
+          </a:prstGeom>
+          <a:noFill/>
+        </p:spPr>
+        <p:txBody>
+          <a:bodyPr wrap="square" anchor="t">
+            <a:spAutoFit/>
+          </a:bodyPr>
+          <a:lstStyle/>
+          <a:p>
+            <a:pPr algn="l"/>
+            <a:r>
+              <a:rPr sz="1800" b="1">
+                <a:solidFill>
+                  <a:srgbClr val="4ADFCB"/>
+                </a:solidFill>
+                <a:latin typeface="Consolas"/>
+              </a:rPr>
+              <a:t>{{PARTE_1_CODIGO}}</a:t>
+            </a:r>
+          </a:p>
+        </p:txBody>
+      </p:sp>
+      <p:sp>
+        <p:nvSpPr>
+          <p:cNvPr id="14" name="TextBox 13"/>
+          <p:cNvSpPr txBox="1"/>
+          <p:nvPr/>
+        </p:nvSpPr>
+        <p:spPr>
+          <a:xfrm>
+            <a:off x="731520" y="3383280"/>
+            <a:ext cx="5135727" cy="502919"/>
+          </a:xfrm>
+          <a:prstGeom prst="rect">
+            <a:avLst/>
+          </a:prstGeom>
+          <a:noFill/>
+        </p:spPr>
+        <p:txBody>
+          <a:bodyPr wrap="square" anchor="t">
+            <a:spAutoFit/>
+          </a:bodyPr>
+          <a:lstStyle/>
+          <a:p>
+            <a:pPr algn="l"/>
+            <a:r>
+              <a:rPr sz="1500" b="0">
+                <a:solidFill>
+                  <a:srgbClr val="FFFFFF"/>
+                </a:solidFill>
+                <a:latin typeface="Calibri"/>
+              </a:rPr>
+              <a:t>{{PARTE_1_DESC}}</a:t>
+            </a:r>
+          </a:p>
+        </p:txBody>
+      </p:sp>
+      <p:sp>
+        <p:nvSpPr>
+          <p:cNvPr id="15" name="Rectangle 14"/>
+          <p:cNvSpPr/>
+          <p:nvPr/>
+        </p:nvSpPr>
+        <p:spPr>
+          <a:xfrm>
+            <a:off x="6233007" y="2651760"/>
+            <a:ext cx="5410047" cy="1280160"/>
+          </a:xfrm>
+          <a:prstGeom prst="rect">
+            <a:avLst/>
+          </a:prstGeom>
+          <a:solidFill>
+            <a:srgbClr val="16213E"/>
+          </a:solidFill>
+          <a:ln>
+            <a:noFill/>
+          </a:ln>
+          <a:effectLst/>
+        </p:spPr>
+        <p:style>
+          <a:lnRef idx="1">
+            <a:schemeClr val="accent1"/>
+          </a:lnRef>
+          <a:fillRef idx="3">
+            <a:schemeClr val="accent1"/>
+          </a:fillRef>
+          <a:effectRef idx="2">
+            <a:schemeClr val="accent1"/>
+          </a:effectRef>
+          <a:fontRef idx="minor">
+            <a:schemeClr val="lt1"/>
+          </a:fontRef>
+        </p:style>
+        <p:txBody>
+          <a:bodyPr rtlCol="0" anchor="ctr"/>
+          <a:lstStyle/>
+          <a:p>
+            <a:pPr algn="ctr"/>
+          </a:p>
+        </p:txBody>
+      </p:sp>
+      <p:sp>
+        <p:nvSpPr>
+          <p:cNvPr id="16" name="Rectangle 15"/>
+          <p:cNvSpPr/>
+          <p:nvPr/>
+        </p:nvSpPr>
+        <p:spPr>
+          <a:xfrm>
+            <a:off x="6233007" y="2651760"/>
+            <a:ext cx="73152" cy="1280160"/>
+          </a:xfrm>
+          <a:prstGeom prst="rect">
+            <a:avLst/>
+          </a:prstGeom>
+          <a:solidFill>
+            <a:srgbClr val="F5A623"/>
+          </a:solidFill>
+          <a:ln>
+            <a:noFill/>
+          </a:ln>
+          <a:effectLst/>
+        </p:spPr>
+        <p:style>
+          <a:lnRef idx="1">
+            <a:schemeClr val="accent1"/>
+          </a:lnRef>
+          <a:fillRef idx="3">
+            <a:schemeClr val="accent1"/>
+          </a:fillRef>
+          <a:effectRef idx="2">
+            <a:schemeClr val="accent1"/>
+          </a:effectRef>
+          <a:fontRef idx="minor">
+            <a:schemeClr val="lt1"/>
+          </a:fontRef>
+        </p:style>
+        <p:txBody>
+          <a:bodyPr rtlCol="0" anchor="ctr"/>
+          <a:lstStyle/>
+          <a:p>
+            <a:pPr algn="ctr"/>
+          </a:p>
+        </p:txBody>
+      </p:sp>
+      <p:sp>
+        <p:nvSpPr>
+          <p:cNvPr id="17" name="TextBox 16"/>
+          <p:cNvSpPr txBox="1"/>
+          <p:nvPr/>
+        </p:nvSpPr>
+        <p:spPr>
+          <a:xfrm>
+            <a:off x="6415887" y="2724912"/>
+            <a:ext cx="5135727" cy="274320"/>
+          </a:xfrm>
+          <a:prstGeom prst="rect">
+            <a:avLst/>
+          </a:prstGeom>
+          <a:noFill/>
+        </p:spPr>
+        <p:txBody>
+          <a:bodyPr wrap="square" anchor="t">
+            <a:spAutoFit/>
+          </a:bodyPr>
+          <a:lstStyle/>
+          <a:p>
+            <a:pPr algn="l"/>
+            <a:r>
+              <a:rPr sz="1200" b="1">
+                <a:solidFill>
+                  <a:srgbClr val="F5A623"/>
+                </a:solidFill>
+                <a:latin typeface="Calibri"/>
+              </a:rPr>
+              <a:t>{{PARTE_2_LABEL}}</a:t>
+            </a:r>
+          </a:p>
+        </p:txBody>
+      </p:sp>
+      <p:sp>
+        <p:nvSpPr>
+          <p:cNvPr id="18" name="TextBox 17"/>
+          <p:cNvSpPr txBox="1"/>
+          <p:nvPr/>
+        </p:nvSpPr>
+        <p:spPr>
+          <a:xfrm>
+            <a:off x="6415887" y="2999232"/>
+            <a:ext cx="5135727" cy="365760"/>
+          </a:xfrm>
+          <a:prstGeom prst="rect">
+            <a:avLst/>
+          </a:prstGeom>
+          <a:noFill/>
+        </p:spPr>
+        <p:txBody>
+          <a:bodyPr wrap="square" anchor="t">
+            <a:spAutoFit/>
+          </a:bodyPr>
+          <a:lstStyle/>
+          <a:p>
+            <a:pPr algn="l"/>
+            <a:r>
+              <a:rPr sz="1800" b="1">
+                <a:solidFill>
+                  <a:srgbClr val="4ADFCB"/>
+                </a:solidFill>
+                <a:latin typeface="Consolas"/>
+              </a:rPr>
+              <a:t>{{PARTE_2_CODIGO}}</a:t>
+            </a:r>
+          </a:p>
+        </p:txBody>
+      </p:sp>
+      <p:sp>
+        <p:nvSpPr>
+          <p:cNvPr id="19" name="TextBox 18"/>
+          <p:cNvSpPr txBox="1"/>
+          <p:nvPr/>
+        </p:nvSpPr>
+        <p:spPr>
+          <a:xfrm>
+            <a:off x="6415887" y="3383280"/>
+            <a:ext cx="5135727" cy="502919"/>
+          </a:xfrm>
+          <a:prstGeom prst="rect">
+            <a:avLst/>
+          </a:prstGeom>
+          <a:noFill/>
+        </p:spPr>
+        <p:txBody>
+          <a:bodyPr wrap="square" anchor="t">
+            <a:spAutoFit/>
+          </a:bodyPr>
+          <a:lstStyle/>
+          <a:p>
+            <a:pPr algn="l"/>
+            <a:r>
+              <a:rPr sz="1500" b="0">
+                <a:solidFill>
+                  <a:srgbClr val="FFFFFF"/>
+                </a:solidFill>
+                <a:latin typeface="Calibri"/>
+              </a:rPr>
+              <a:t>{{PARTE_2_DESC}}</a:t>
+            </a:r>
+          </a:p>
+        </p:txBody>
+      </p:sp>
+      <p:sp>
+        <p:nvSpPr>
+          <p:cNvPr id="20" name="Rectangle 19"/>
+          <p:cNvSpPr/>
+          <p:nvPr/>
+        </p:nvSpPr>
+        <p:spPr>
+          <a:xfrm>
+            <a:off x="548640" y="4114800"/>
+            <a:ext cx="5410047" cy="1280160"/>
+          </a:xfrm>
+          <a:prstGeom prst="rect">
+            <a:avLst/>
+          </a:prstGeom>
+          <a:solidFill>
+            <a:srgbClr val="16213E"/>
+          </a:solidFill>
+          <a:ln>
+            <a:noFill/>
+          </a:ln>
+          <a:effectLst/>
+        </p:spPr>
+        <p:style>
+          <a:lnRef idx="1">
+            <a:schemeClr val="accent1"/>
+          </a:lnRef>
+          <a:fillRef idx="3">
+            <a:schemeClr val="accent1"/>
+          </a:fillRef>
+          <a:effectRef idx="2">
+            <a:schemeClr val="accent1"/>
+          </a:effectRef>
+          <a:fontRef idx="minor">
+            <a:schemeClr val="lt1"/>
+          </a:fontRef>
+        </p:style>
+        <p:txBody>
+          <a:bodyPr rtlCol="0" anchor="ctr"/>
+          <a:lstStyle/>
+          <a:p>
+            <a:pPr algn="ctr"/>
+          </a:p>
+        </p:txBody>
+      </p:sp>
+      <p:sp>
+        <p:nvSpPr>
+          <p:cNvPr id="21" name="Rectangle 20"/>
+          <p:cNvSpPr/>
+          <p:nvPr/>
+        </p:nvSpPr>
+        <p:spPr>
+          <a:xfrm>
+            <a:off x="548640" y="4114800"/>
+            <a:ext cx="73152" cy="1280160"/>
+          </a:xfrm>
+          <a:prstGeom prst="rect">
+            <a:avLst/>
+          </a:prstGeom>
+          <a:solidFill>
+            <a:srgbClr val="02C39A"/>
+          </a:solidFill>
+          <a:ln>
+            <a:noFill/>
+          </a:ln>
+          <a:effectLst/>
+        </p:spPr>
+        <p:style>
+          <a:lnRef idx="1">
+            <a:schemeClr val="accent1"/>
+          </a:lnRef>
+          <a:fillRef idx="3">
+            <a:schemeClr val="accent1"/>
+          </a:fillRef>
+          <a:effectRef idx="2">
+            <a:schemeClr val="accent1"/>
+          </a:effectRef>
+          <a:fontRef idx="minor">
+            <a:schemeClr val="lt1"/>
+          </a:fontRef>
+        </p:style>
+        <p:txBody>
+          <a:bodyPr rtlCol="0" anchor="ctr"/>
+          <a:lstStyle/>
+          <a:p>
+            <a:pPr algn="ctr"/>
+          </a:p>
+        </p:txBody>
+      </p:sp>
+      <p:sp>
+        <p:nvSpPr>
+          <p:cNvPr id="22" name="TextBox 21"/>
+          <p:cNvSpPr txBox="1"/>
+          <p:nvPr/>
+        </p:nvSpPr>
+        <p:spPr>
+          <a:xfrm>
+            <a:off x="731520" y="4187952"/>
+            <a:ext cx="5135727" cy="274320"/>
+          </a:xfrm>
+          <a:prstGeom prst="rect">
+            <a:avLst/>
+          </a:prstGeom>
+          <a:noFill/>
+        </p:spPr>
+        <p:txBody>
+          <a:bodyPr wrap="square" anchor="t">
+            <a:spAutoFit/>
+          </a:bodyPr>
+          <a:lstStyle/>
+          <a:p>
+            <a:pPr algn="l"/>
+            <a:r>
+              <a:rPr sz="1200" b="1">
+                <a:solidFill>
+                  <a:srgbClr val="F5A623"/>
+                </a:solidFill>
+                <a:latin typeface="Calibri"/>
+              </a:rPr>
+              <a:t>{{PARTE_3_LABEL}}</a:t>
+            </a:r>
+          </a:p>
+        </p:txBody>
+      </p:sp>
+      <p:sp>
+        <p:nvSpPr>
+          <p:cNvPr id="23" name="TextBox 22"/>
+          <p:cNvSpPr txBox="1"/>
+          <p:nvPr/>
+        </p:nvSpPr>
+        <p:spPr>
+          <a:xfrm>
+            <a:off x="731520" y="4462272"/>
+            <a:ext cx="5135727" cy="365760"/>
+          </a:xfrm>
+          <a:prstGeom prst="rect">
+            <a:avLst/>
+          </a:prstGeom>
+          <a:noFill/>
+        </p:spPr>
+        <p:txBody>
+          <a:bodyPr wrap="square" anchor="t">
+            <a:spAutoFit/>
+          </a:bodyPr>
+          <a:lstStyle/>
+          <a:p>
+            <a:pPr algn="l"/>
+            <a:r>
+              <a:rPr sz="1800" b="1">
+                <a:solidFill>
+                  <a:srgbClr val="4ADFCB"/>
+                </a:solidFill>
+                <a:latin typeface="Consolas"/>
+              </a:rPr>
+              <a:t>{{PARTE_3_CODIGO}}</a:t>
+            </a:r>
+          </a:p>
+        </p:txBody>
+      </p:sp>
+      <p:sp>
+        <p:nvSpPr>
+          <p:cNvPr id="24" name="TextBox 23"/>
+          <p:cNvSpPr txBox="1"/>
+          <p:nvPr/>
+        </p:nvSpPr>
+        <p:spPr>
+          <a:xfrm>
+            <a:off x="731520" y="4846320"/>
+            <a:ext cx="5135727" cy="502919"/>
+          </a:xfrm>
+          <a:prstGeom prst="rect">
+            <a:avLst/>
+          </a:prstGeom>
+          <a:noFill/>
+        </p:spPr>
+        <p:txBody>
+          <a:bodyPr wrap="square" anchor="t">
+            <a:spAutoFit/>
+          </a:bodyPr>
+          <a:lstStyle/>
+          <a:p>
+            <a:pPr algn="l"/>
+            <a:r>
+              <a:rPr sz="1500" b="0">
+                <a:solidFill>
+                  <a:srgbClr val="FFFFFF"/>
+                </a:solidFill>
+                <a:latin typeface="Calibri"/>
+              </a:rPr>
+              <a:t>{{PARTE_3_DESC}}</a:t>
+            </a:r>
+          </a:p>
+        </p:txBody>
+      </p:sp>
+      <p:sp>
+        <p:nvSpPr>
+          <p:cNvPr id="25" name="Rectangle 24"/>
+          <p:cNvSpPr/>
+          <p:nvPr/>
+        </p:nvSpPr>
+        <p:spPr>
+          <a:xfrm>
+            <a:off x="6233007" y="4114800"/>
+            <a:ext cx="5410047" cy="1280160"/>
+          </a:xfrm>
+          <a:prstGeom prst="rect">
+            <a:avLst/>
+          </a:prstGeom>
+          <a:solidFill>
+            <a:srgbClr val="16213E"/>
+          </a:solidFill>
+          <a:ln>
+            <a:noFill/>
+          </a:ln>
+          <a:effectLst/>
+        </p:spPr>
+        <p:style>
+          <a:lnRef idx="1">
+            <a:schemeClr val="accent1"/>
+          </a:lnRef>
+          <a:fillRef idx="3">
+            <a:schemeClr val="accent1"/>
+          </a:fillRef>
+          <a:effectRef idx="2">
+            <a:schemeClr val="accent1"/>
+          </a:effectRef>
+          <a:fontRef idx="minor">
+            <a:schemeClr val="lt1"/>
+          </a:fontRef>
+        </p:style>
+        <p:txBody>
+          <a:bodyPr rtlCol="0" anchor="ctr"/>
+          <a:lstStyle/>
+          <a:p>
+            <a:pPr algn="ctr"/>
+          </a:p>
+        </p:txBody>
+      </p:sp>
+      <p:sp>
+        <p:nvSpPr>
+          <p:cNvPr id="26" name="Rectangle 25"/>
+          <p:cNvSpPr/>
+          <p:nvPr/>
+        </p:nvSpPr>
+        <p:spPr>
+          <a:xfrm>
+            <a:off x="6233007" y="4114800"/>
+            <a:ext cx="73152" cy="1280160"/>
+          </a:xfrm>
+          <a:prstGeom prst="rect">
+            <a:avLst/>
+          </a:prstGeom>
+          <a:solidFill>
+            <a:srgbClr val="F5A623"/>
+          </a:solidFill>
+          <a:ln>
+            <a:noFill/>
+          </a:ln>
+          <a:effectLst/>
+        </p:spPr>
+        <p:style>
+          <a:lnRef idx="1">
+            <a:schemeClr val="accent1"/>
+          </a:lnRef>
+          <a:fillRef idx="3">
+            <a:schemeClr val="accent1"/>
+          </a:fillRef>
+          <a:effectRef idx="2">
+            <a:schemeClr val="accent1"/>
+          </a:effectRef>
+          <a:fontRef idx="minor">
+            <a:schemeClr val="lt1"/>
+          </a:fontRef>
+        </p:style>
+        <p:txBody>
+          <a:bodyPr rtlCol="0" anchor="ctr"/>
+          <a:lstStyle/>
+          <a:p>
+            <a:pPr algn="ctr"/>
+          </a:p>
+        </p:txBody>
+      </p:sp>
+      <p:sp>
+        <p:nvSpPr>
+          <p:cNvPr id="27" name="TextBox 26"/>
+          <p:cNvSpPr txBox="1"/>
+          <p:nvPr/>
+        </p:nvSpPr>
+        <p:spPr>
+          <a:xfrm>
+            <a:off x="6415887" y="4187952"/>
+            <a:ext cx="5135727" cy="274320"/>
+          </a:xfrm>
+          <a:prstGeom prst="rect">
+            <a:avLst/>
+          </a:prstGeom>
+          <a:noFill/>
+        </p:spPr>
+        <p:txBody>
+          <a:bodyPr wrap="square" anchor="t">
+            <a:spAutoFit/>
+          </a:bodyPr>
+          <a:lstStyle/>
+          <a:p>
+            <a:pPr algn="l"/>
+            <a:r>
+              <a:rPr sz="1200" b="1">
+                <a:solidFill>
+                  <a:srgbClr val="F5A623"/>
+                </a:solidFill>
+                <a:latin typeface="Calibri"/>
+              </a:rPr>
+              <a:t>{{PARTE_4_LABEL}}</a:t>
+            </a:r>
+          </a:p>
+        </p:txBody>
+      </p:sp>
+      <p:sp>
+        <p:nvSpPr>
+          <p:cNvPr id="28" name="TextBox 27"/>
+          <p:cNvSpPr txBox="1"/>
+          <p:nvPr/>
+        </p:nvSpPr>
+        <p:spPr>
+          <a:xfrm>
+            <a:off x="6415887" y="4462272"/>
+            <a:ext cx="5135727" cy="365760"/>
+          </a:xfrm>
+          <a:prstGeom prst="rect">
+            <a:avLst/>
+          </a:prstGeom>
+          <a:noFill/>
+        </p:spPr>
+        <p:txBody>
+          <a:bodyPr wrap="square" anchor="t">
+            <a:spAutoFit/>
+          </a:bodyPr>
+          <a:lstStyle/>
+          <a:p>
+            <a:pPr algn="l"/>
+            <a:r>
+              <a:rPr sz="1800" b="1">
+                <a:solidFill>
+                  <a:srgbClr val="4ADFCB"/>
+                </a:solidFill>
+                <a:latin typeface="Consolas"/>
+              </a:rPr>
+              <a:t>{{PARTE_4_CODIGO}}</a:t>
+            </a:r>
+          </a:p>
+        </p:txBody>
+      </p:sp>
+      <p:sp>
+        <p:nvSpPr>
+          <p:cNvPr id="29" name="TextBox 28"/>
+          <p:cNvSpPr txBox="1"/>
+          <p:nvPr/>
+        </p:nvSpPr>
+        <p:spPr>
+          <a:xfrm>
+            <a:off x="6415887" y="4846320"/>
+            <a:ext cx="5135727" cy="502919"/>
+          </a:xfrm>
+          <a:prstGeom prst="rect">
+            <a:avLst/>
+          </a:prstGeom>
+          <a:noFill/>
+        </p:spPr>
+        <p:txBody>
+          <a:bodyPr wrap="square" anchor="t">
+            <a:spAutoFit/>
+          </a:bodyPr>
+          <a:lstStyle/>
+          <a:p>
+            <a:pPr algn="l"/>
+            <a:r>
+              <a:rPr sz="1500" b="0">
+                <a:solidFill>
+                  <a:srgbClr val="FFFFFF"/>
+                </a:solidFill>
+                <a:latin typeface="Calibri"/>
+              </a:rPr>
+              <a:t>{{PARTE_4_DESC}}</a:t>
+            </a:r>
+          </a:p>
+        </p:txBody>
+      </p:sp>
+      <p:sp>
+        <p:nvSpPr>
+          <p:cNvPr id="30" name="Rectangle 29"/>
+          <p:cNvSpPr/>
+          <p:nvPr/>
+        </p:nvSpPr>
+        <p:spPr>
+          <a:xfrm>
+            <a:off x="548640" y="6080760"/>
+            <a:ext cx="11094415" cy="594360"/>
+          </a:xfrm>
+          <a:prstGeom prst="rect">
+            <a:avLst/>
+          </a:prstGeom>
+          <a:solidFill>
+            <a:srgbClr val="16213E"/>
+          </a:solidFill>
+          <a:ln>
+            <a:noFill/>
+          </a:ln>
+          <a:effectLst/>
+        </p:spPr>
+        <p:style>
+          <a:lnRef idx="1">
+            <a:schemeClr val="accent1"/>
+          </a:lnRef>
+          <a:fillRef idx="3">
+            <a:schemeClr val="accent1"/>
+          </a:fillRef>
+          <a:effectRef idx="2">
+            <a:schemeClr val="accent1"/>
+          </a:effectRef>
+          <a:fontRef idx="minor">
+            <a:schemeClr val="lt1"/>
+          </a:fontRef>
+        </p:style>
+        <p:txBody>
+          <a:bodyPr rtlCol="0" anchor="ctr"/>
+          <a:lstStyle/>
+          <a:p>
+            <a:pPr algn="ctr"/>
+          </a:p>
+        </p:txBody>
+      </p:sp>
+      <p:sp>
+        <p:nvSpPr>
+          <p:cNvPr id="31" name="Rectangle 30"/>
+          <p:cNvSpPr/>
+          <p:nvPr/>
+        </p:nvSpPr>
+        <p:spPr>
+          <a:xfrm>
+            <a:off x="548640" y="6080760"/>
+            <a:ext cx="73152" cy="594360"/>
+          </a:xfrm>
+          <a:prstGeom prst="rect">
+            <a:avLst/>
+          </a:prstGeom>
+          <a:solidFill>
+            <a:srgbClr val="F5A623"/>
+          </a:solidFill>
+          <a:ln>
+            <a:noFill/>
+          </a:ln>
+          <a:effectLst/>
+        </p:spPr>
+        <p:style>
+          <a:lnRef idx="1">
+            <a:schemeClr val="accent1"/>
+          </a:lnRef>
+          <a:fillRef idx="3">
+            <a:schemeClr val="accent1"/>
+          </a:fillRef>
+          <a:effectRef idx="2">
+            <a:schemeClr val="accent1"/>
+          </a:effectRef>
+          <a:fontRef idx="minor">
+            <a:schemeClr val="lt1"/>
+          </a:fontRef>
+        </p:style>
+        <p:txBody>
+          <a:bodyPr rtlCol="0" anchor="ctr"/>
+          <a:lstStyle/>
+          <a:p>
+            <a:pPr algn="ctr"/>
+          </a:p>
+        </p:txBody>
+      </p:sp>
+      <p:sp>
+        <p:nvSpPr>
+          <p:cNvPr id="32" name="TextBox 31"/>
+          <p:cNvSpPr txBox="1"/>
+          <p:nvPr/>
+        </p:nvSpPr>
+        <p:spPr>
+          <a:xfrm>
+            <a:off x="777240" y="6126480"/>
+            <a:ext cx="10728655" cy="502920"/>
+          </a:xfrm>
+          <a:prstGeom prst="rect">
+            <a:avLst/>
+          </a:prstGeom>
+          <a:noFill/>
+        </p:spPr>
+        <p:txBody>
+          <a:bodyPr wrap="square" anchor="ctr">
+            <a:spAutoFit/>
+          </a:bodyPr>
+          <a:lstStyle/>
+          <a:p>
+            <a:pPr algn="l"/>
+            <a:r>
+              <a:rPr sz="1600" b="0">
+                <a:solidFill>
+                  <a:srgbClr val="FFFFFF"/>
+                </a:solidFill>
+                <a:latin typeface="Calibri"/>
+              </a:rPr>
+              <a:t>💡  {{IDEA_CLAVE}}</a:t>
+            </a:r>
+          </a:p>
+        </p:txBody>
+      </p:sp>
+    </p:spTree>
+  </p:cSld>
+  <p:clrMapOvr>
+    <a:masterClrMapping/>
+  </p:clrMapOvr>
+</p:sld>
+</file>
+
+<file path=ppt/slides/slide12.xml><?xml version="1.0" encoding="utf-8"?>
+<p:sld xmlns:a="http://schemas.openxmlformats.org/drawingml/2006/main" xmlns:p="http://schemas.openxmlformats.org/presentationml/2006/main" xmlns:r="http://schemas.openxmlformats.org/officeDocument/2006/relationships">
+  <p:cSld>
+    <p:spTree>
+      <p:nvGrpSpPr>
+        <p:cNvPr id="1" name=""/>
+        <p:cNvGrpSpPr/>
+        <p:nvPr/>
+      </p:nvGrpSpPr>
+      <p:grpSpPr/>
+      <p:sp>
+        <p:nvSpPr>
+          <p:cNvPr id="2" name="Rectangle 1"/>
+          <p:cNvSpPr/>
+          <p:nvPr/>
+        </p:nvSpPr>
+        <p:spPr>
+          <a:xfrm>
+            <a:off x="0" y="0"/>
+            <a:ext cx="12191695" cy="6858000"/>
+          </a:xfrm>
+          <a:prstGeom prst="rect">
+            <a:avLst/>
+          </a:prstGeom>
+          <a:solidFill>
+            <a:srgbClr val="1A1A2E"/>
+          </a:solidFill>
+          <a:ln>
+            <a:noFill/>
+          </a:ln>
+          <a:effectLst/>
+        </p:spPr>
+        <p:style>
+          <a:lnRef idx="1">
+            <a:schemeClr val="accent1"/>
+          </a:lnRef>
+          <a:fillRef idx="3">
+            <a:schemeClr val="accent1"/>
+          </a:fillRef>
+          <a:effectRef idx="2">
+            <a:schemeClr val="accent1"/>
+          </a:effectRef>
+          <a:fontRef idx="minor">
+            <a:schemeClr val="lt1"/>
+          </a:fontRef>
+        </p:style>
+        <p:txBody>
+          <a:bodyPr rtlCol="0" anchor="ctr"/>
+          <a:lstStyle/>
+          <a:p>
+            <a:pPr algn="ctr"/>
+          </a:p>
+        </p:txBody>
+      </p:sp>
+      <p:sp>
+        <p:nvSpPr>
+          <p:cNvPr id="3" name="Rectangle 2"/>
+          <p:cNvSpPr/>
+          <p:nvPr/>
+        </p:nvSpPr>
+        <p:spPr>
+          <a:xfrm>
+            <a:off x="0" y="0"/>
+            <a:ext cx="12191695" cy="502920"/>
+          </a:xfrm>
+          <a:prstGeom prst="rect">
+            <a:avLst/>
+          </a:prstGeom>
+          <a:solidFill>
+            <a:srgbClr val="0F162A"/>
+          </a:solidFill>
+          <a:ln>
+            <a:noFill/>
+          </a:ln>
+          <a:effectLst/>
+        </p:spPr>
+        <p:style>
+          <a:lnRef idx="1">
+            <a:schemeClr val="accent1"/>
+          </a:lnRef>
+          <a:fillRef idx="3">
+            <a:schemeClr val="accent1"/>
+          </a:fillRef>
+          <a:effectRef idx="2">
+            <a:schemeClr val="accent1"/>
+          </a:effectRef>
+          <a:fontRef idx="minor">
+            <a:schemeClr val="lt1"/>
+          </a:fontRef>
+        </p:style>
+        <p:txBody>
+          <a:bodyPr rtlCol="0" anchor="ctr"/>
+          <a:lstStyle/>
+          <a:p>
+            <a:pPr algn="ctr"/>
+          </a:p>
+        </p:txBody>
+      </p:sp>
+      <p:sp>
+        <p:nvSpPr>
+          <p:cNvPr id="4" name="TextBox 3"/>
+          <p:cNvSpPr txBox="1"/>
+          <p:nvPr/>
+        </p:nvSpPr>
+        <p:spPr>
+          <a:xfrm>
+            <a:off x="411479" y="118872"/>
+            <a:ext cx="5486400" cy="320040"/>
+          </a:xfrm>
+          <a:prstGeom prst="rect">
+            <a:avLst/>
+          </a:prstGeom>
+          <a:noFill/>
+        </p:spPr>
+        <p:txBody>
+          <a:bodyPr wrap="square" anchor="ctr">
+            <a:spAutoFit/>
+          </a:bodyPr>
+          <a:lstStyle/>
+          <a:p>
+            <a:pPr algn="l"/>
+            <a:r>
+              <a:rPr sz="1200" b="0">
+                <a:solidFill>
+                  <a:srgbClr val="94A3B8"/>
+                </a:solidFill>
+                <a:latin typeface="Consolas"/>
+              </a:rPr>
+              <a:t>🐍 Python · Clase {{NUMERO_CLASE}}</a:t>
+            </a:r>
+          </a:p>
+        </p:txBody>
+      </p:sp>
+      <p:sp>
+        <p:nvSpPr>
+          <p:cNvPr id="5" name="TextBox 4"/>
+          <p:cNvSpPr txBox="1"/>
+          <p:nvPr/>
+        </p:nvSpPr>
+        <p:spPr>
+          <a:xfrm>
+            <a:off x="8534095" y="118872"/>
+            <a:ext cx="3200400" cy="320040"/>
+          </a:xfrm>
+          <a:prstGeom prst="rect">
+            <a:avLst/>
+          </a:prstGeom>
+          <a:noFill/>
+        </p:spPr>
+        <p:txBody>
+          <a:bodyPr wrap="square" anchor="ctr">
+            <a:spAutoFit/>
+          </a:bodyPr>
+          <a:lstStyle/>
+          <a:p>
+            <a:pPr algn="r"/>
+            <a:r>
+              <a:rPr sz="1200" b="1">
+                <a:solidFill>
+                  <a:srgbClr val="0F9B8E"/>
+                </a:solidFill>
+                <a:latin typeface="Consolas"/>
+              </a:rPr>
+              <a:t>{{SECCION}}</a:t>
+            </a:r>
+          </a:p>
+        </p:txBody>
+      </p:sp>
+      <p:sp>
+        <p:nvSpPr>
+          <p:cNvPr id="6" name="TextBox 5"/>
+          <p:cNvSpPr txBox="1"/>
+          <p:nvPr/>
+        </p:nvSpPr>
+        <p:spPr>
+          <a:xfrm>
+            <a:off x="548640" y="868680"/>
+            <a:ext cx="11094415" cy="685800"/>
+          </a:xfrm>
+          <a:prstGeom prst="rect">
+            <a:avLst/>
+          </a:prstGeom>
+          <a:noFill/>
+        </p:spPr>
+        <p:txBody>
+          <a:bodyPr wrap="square" anchor="t">
+            <a:spAutoFit/>
+          </a:bodyPr>
+          <a:lstStyle/>
+          <a:p>
+            <a:pPr algn="l"/>
+            <a:r>
+              <a:rPr sz="3200" b="1">
+                <a:solidFill>
+                  <a:srgbClr val="FFFFFF"/>
+                </a:solidFill>
+                <a:latin typeface="Calibri"/>
+              </a:rPr>
+              <a:t>{{TITULO_SLIDE}}</a:t>
+            </a:r>
+          </a:p>
+        </p:txBody>
+      </p:sp>
+      <p:sp>
+        <p:nvSpPr>
+          <p:cNvPr id="7" name="TextBox 6"/>
+          <p:cNvSpPr txBox="1"/>
+          <p:nvPr/>
+        </p:nvSpPr>
+        <p:spPr>
+          <a:xfrm>
+            <a:off x="548640" y="1508760"/>
+            <a:ext cx="11094415" cy="365760"/>
+          </a:xfrm>
+          <a:prstGeom prst="rect">
+            <a:avLst/>
+          </a:prstGeom>
+          <a:noFill/>
+        </p:spPr>
+        <p:txBody>
+          <a:bodyPr wrap="square" anchor="t">
+            <a:spAutoFit/>
+          </a:bodyPr>
+          <a:lstStyle/>
+          <a:p>
+            <a:pPr algn="l"/>
+            <a:r>
+              <a:rPr sz="2200" b="0">
+                <a:solidFill>
+                  <a:srgbClr val="FFFFFF"/>
+                </a:solidFill>
+                <a:latin typeface="Calibri"/>
+              </a:rPr>
+              <a:t>{{SUBTITULO_SLIDE}}</a:t>
+            </a:r>
+          </a:p>
+        </p:txBody>
+      </p:sp>
+      <p:sp>
+        <p:nvSpPr>
+          <p:cNvPr id="8" name="TextBox 7"/>
+          <p:cNvSpPr txBox="1"/>
+          <p:nvPr/>
+        </p:nvSpPr>
+        <p:spPr>
+          <a:xfrm>
+            <a:off x="548640" y="2011680"/>
+            <a:ext cx="5166360" cy="320040"/>
+          </a:xfrm>
+          <a:prstGeom prst="rect">
+            <a:avLst/>
+          </a:prstGeom>
+          <a:noFill/>
+        </p:spPr>
+        <p:txBody>
+          <a:bodyPr wrap="square" anchor="t">
+            <a:spAutoFit/>
+          </a:bodyPr>
+          <a:lstStyle/>
+          <a:p>
+            <a:pPr algn="l"/>
+            <a:r>
+              <a:rPr sz="1800" b="1">
+                <a:solidFill>
+                  <a:srgbClr val="F5A623"/>
+                </a:solidFill>
+                <a:latin typeface="Calibri"/>
+              </a:rPr>
+              <a:t>🌍  Vida real</a:t>
+            </a:r>
+          </a:p>
+        </p:txBody>
+      </p:sp>
+      <p:sp>
+        <p:nvSpPr>
+          <p:cNvPr id="9" name="TextBox 8"/>
+          <p:cNvSpPr txBox="1"/>
+          <p:nvPr/>
+        </p:nvSpPr>
+        <p:spPr>
+          <a:xfrm>
+            <a:off x="6172200" y="2011680"/>
+            <a:ext cx="5470855" cy="320040"/>
+          </a:xfrm>
+          <a:prstGeom prst="rect">
+            <a:avLst/>
+          </a:prstGeom>
+          <a:noFill/>
+        </p:spPr>
+        <p:txBody>
+          <a:bodyPr wrap="square" anchor="t">
+            <a:spAutoFit/>
+          </a:bodyPr>
+          <a:lstStyle/>
+          <a:p>
+            <a:pPr algn="l"/>
+            <a:r>
+              <a:rPr sz="1800" b="1">
+                <a:solidFill>
+                  <a:srgbClr val="0F9B8E"/>
+                </a:solidFill>
+                <a:latin typeface="Calibri"/>
+              </a:rPr>
+              <a:t>🐍  En Python</a:t>
+            </a:r>
+          </a:p>
+        </p:txBody>
+      </p:sp>
+      <p:sp>
+        <p:nvSpPr>
+          <p:cNvPr id="10" name="Rectangle 9"/>
+          <p:cNvSpPr/>
+          <p:nvPr/>
+        </p:nvSpPr>
+        <p:spPr>
+          <a:xfrm>
+            <a:off x="548640" y="2423160"/>
+            <a:ext cx="5166360" cy="777240"/>
+          </a:xfrm>
+          <a:prstGeom prst="rect">
+            <a:avLst/>
+          </a:prstGeom>
+          <a:solidFill>
+            <a:srgbClr val="16213E"/>
+          </a:solidFill>
+          <a:ln>
+            <a:noFill/>
+          </a:ln>
+          <a:effectLst/>
+        </p:spPr>
+        <p:style>
+          <a:lnRef idx="1">
+            <a:schemeClr val="accent1"/>
+          </a:lnRef>
+          <a:fillRef idx="3">
+            <a:schemeClr val="accent1"/>
+          </a:fillRef>
+          <a:effectRef idx="2">
+            <a:schemeClr val="accent1"/>
+          </a:effectRef>
+          <a:fontRef idx="minor">
+            <a:schemeClr val="lt1"/>
+          </a:fontRef>
+        </p:style>
+        <p:txBody>
+          <a:bodyPr rtlCol="0" anchor="ctr"/>
+          <a:lstStyle/>
+          <a:p>
+            <a:pPr algn="ctr"/>
+          </a:p>
+        </p:txBody>
+      </p:sp>
+      <p:sp>
+        <p:nvSpPr>
+          <p:cNvPr id="11" name="Rectangle 10"/>
+          <p:cNvSpPr/>
+          <p:nvPr/>
+        </p:nvSpPr>
+        <p:spPr>
+          <a:xfrm>
+            <a:off x="548640" y="2423160"/>
+            <a:ext cx="54864" cy="777240"/>
+          </a:xfrm>
+          <a:prstGeom prst="rect">
+            <a:avLst/>
+          </a:prstGeom>
+          <a:solidFill>
+            <a:srgbClr val="F5A623"/>
+          </a:solidFill>
+          <a:ln>
+            <a:noFill/>
+          </a:ln>
+          <a:effectLst/>
+        </p:spPr>
+        <p:style>
+          <a:lnRef idx="1">
+            <a:schemeClr val="accent1"/>
+          </a:lnRef>
+          <a:fillRef idx="3">
+            <a:schemeClr val="accent1"/>
+          </a:fillRef>
+          <a:effectRef idx="2">
+            <a:schemeClr val="accent1"/>
+          </a:effectRef>
+          <a:fontRef idx="minor">
+            <a:schemeClr val="lt1"/>
+          </a:fontRef>
+        </p:style>
+        <p:txBody>
+          <a:bodyPr rtlCol="0" anchor="ctr"/>
+          <a:lstStyle/>
+          <a:p>
+            <a:pPr algn="ctr"/>
+          </a:p>
+        </p:txBody>
+      </p:sp>
+      <p:sp>
+        <p:nvSpPr>
+          <p:cNvPr id="12" name="TextBox 11"/>
+          <p:cNvSpPr txBox="1"/>
+          <p:nvPr/>
+        </p:nvSpPr>
+        <p:spPr>
+          <a:xfrm>
+            <a:off x="713232" y="2496312"/>
+            <a:ext cx="4892040" cy="630936"/>
+          </a:xfrm>
+          <a:prstGeom prst="rect">
+            <a:avLst/>
+          </a:prstGeom>
+          <a:noFill/>
+        </p:spPr>
+        <p:txBody>
+          <a:bodyPr wrap="square" anchor="ctr">
+            <a:spAutoFit/>
+          </a:bodyPr>
+          <a:lstStyle/>
+          <a:p>
+            <a:pPr algn="l"/>
+            <a:r>
+              <a:rPr sz="1600" b="0">
+                <a:solidFill>
+                  <a:srgbClr val="FFFFFF"/>
+                </a:solidFill>
+                <a:latin typeface="Calibri"/>
+              </a:rPr>
+              <a:t>{{FILA_1_VIDA_REAL}}</a:t>
+            </a:r>
+          </a:p>
+        </p:txBody>
+      </p:sp>
+      <p:sp>
+        <p:nvSpPr>
+          <p:cNvPr id="13" name="TextBox 12"/>
+          <p:cNvSpPr txBox="1"/>
+          <p:nvPr/>
+        </p:nvSpPr>
+        <p:spPr>
+          <a:xfrm>
+            <a:off x="5715000" y="2423160"/>
+            <a:ext cx="457200" cy="777240"/>
+          </a:xfrm>
+          <a:prstGeom prst="rect">
+            <a:avLst/>
+          </a:prstGeom>
+          <a:noFill/>
+        </p:spPr>
+        <p:txBody>
+          <a:bodyPr wrap="square" anchor="ctr">
+            <a:spAutoFit/>
+          </a:bodyPr>
+          <a:lstStyle/>
+          <a:p>
+            <a:pPr algn="ctr"/>
+            <a:r>
+              <a:rPr sz="2000" b="1">
+                <a:solidFill>
+                  <a:srgbClr val="0F9B8E"/>
+                </a:solidFill>
+                <a:latin typeface="Calibri"/>
+              </a:rPr>
+              <a:t>↔</a:t>
+            </a:r>
+          </a:p>
+        </p:txBody>
+      </p:sp>
+      <p:sp>
+        <p:nvSpPr>
+          <p:cNvPr id="14" name="Rectangle 13"/>
+          <p:cNvSpPr/>
+          <p:nvPr/>
+        </p:nvSpPr>
+        <p:spPr>
+          <a:xfrm>
+            <a:off x="6172200" y="2423160"/>
+            <a:ext cx="5470855" cy="777240"/>
+          </a:xfrm>
+          <a:prstGeom prst="rect">
+            <a:avLst/>
+          </a:prstGeom>
+          <a:solidFill>
+            <a:srgbClr val="0D1117"/>
+          </a:solidFill>
+          <a:ln>
+            <a:noFill/>
+          </a:ln>
+          <a:effectLst/>
+        </p:spPr>
+        <p:style>
+          <a:lnRef idx="1">
+            <a:schemeClr val="accent1"/>
+          </a:lnRef>
+          <a:fillRef idx="3">
+            <a:schemeClr val="accent1"/>
+          </a:fillRef>
+          <a:effectRef idx="2">
+            <a:schemeClr val="accent1"/>
+          </a:effectRef>
+          <a:fontRef idx="minor">
+            <a:schemeClr val="lt1"/>
+          </a:fontRef>
+        </p:style>
+        <p:txBody>
+          <a:bodyPr rtlCol="0" anchor="ctr"/>
+          <a:lstStyle/>
+          <a:p>
+            <a:pPr algn="ctr"/>
+          </a:p>
+        </p:txBody>
+      </p:sp>
+      <p:sp>
+        <p:nvSpPr>
+          <p:cNvPr id="15" name="Rectangle 14"/>
+          <p:cNvSpPr/>
+          <p:nvPr/>
+        </p:nvSpPr>
+        <p:spPr>
+          <a:xfrm>
+            <a:off x="6172200" y="2423160"/>
+            <a:ext cx="54864" cy="777240"/>
+          </a:xfrm>
+          <a:prstGeom prst="rect">
+            <a:avLst/>
+          </a:prstGeom>
+          <a:solidFill>
+            <a:srgbClr val="0F9B8E"/>
+          </a:solidFill>
+          <a:ln>
+            <a:noFill/>
+          </a:ln>
+          <a:effectLst/>
+        </p:spPr>
+        <p:style>
+          <a:lnRef idx="1">
+            <a:schemeClr val="accent1"/>
+          </a:lnRef>
+          <a:fillRef idx="3">
+            <a:schemeClr val="accent1"/>
+          </a:fillRef>
+          <a:effectRef idx="2">
+            <a:schemeClr val="accent1"/>
+          </a:effectRef>
+          <a:fontRef idx="minor">
+            <a:schemeClr val="lt1"/>
+          </a:fontRef>
+        </p:style>
+        <p:txBody>
+          <a:bodyPr rtlCol="0" anchor="ctr"/>
+          <a:lstStyle/>
+          <a:p>
+            <a:pPr algn="ctr"/>
+          </a:p>
+        </p:txBody>
+      </p:sp>
+      <p:sp>
+        <p:nvSpPr>
+          <p:cNvPr id="16" name="TextBox 15"/>
+          <p:cNvSpPr txBox="1"/>
+          <p:nvPr/>
+        </p:nvSpPr>
+        <p:spPr>
+          <a:xfrm>
+            <a:off x="6336792" y="2496312"/>
+            <a:ext cx="5196535" cy="630936"/>
+          </a:xfrm>
+          <a:prstGeom prst="rect">
+            <a:avLst/>
+          </a:prstGeom>
+          <a:noFill/>
+        </p:spPr>
+        <p:txBody>
+          <a:bodyPr wrap="square" anchor="ctr">
+            <a:spAutoFit/>
+          </a:bodyPr>
+          <a:lstStyle/>
+          <a:p>
+            <a:pPr algn="l"/>
+            <a:r>
+              <a:rPr sz="1600" b="0">
+                <a:solidFill>
+                  <a:srgbClr val="4ADFCB"/>
+                </a:solidFill>
+                <a:latin typeface="Consolas"/>
+              </a:rPr>
+              <a:t>{{FILA_1_PYTHON}}</a:t>
+            </a:r>
+          </a:p>
+        </p:txBody>
+      </p:sp>
+      <p:sp>
+        <p:nvSpPr>
+          <p:cNvPr id="17" name="Rectangle 16"/>
+          <p:cNvSpPr/>
+          <p:nvPr/>
+        </p:nvSpPr>
+        <p:spPr>
+          <a:xfrm>
+            <a:off x="548640" y="3310128"/>
+            <a:ext cx="5166360" cy="777240"/>
+          </a:xfrm>
+          <a:prstGeom prst="rect">
+            <a:avLst/>
+          </a:prstGeom>
+          <a:solidFill>
+            <a:srgbClr val="16213E"/>
+          </a:solidFill>
+          <a:ln>
+            <a:noFill/>
+          </a:ln>
+          <a:effectLst/>
+        </p:spPr>
+        <p:style>
+          <a:lnRef idx="1">
+            <a:schemeClr val="accent1"/>
+          </a:lnRef>
+          <a:fillRef idx="3">
+            <a:schemeClr val="accent1"/>
+          </a:fillRef>
+          <a:effectRef idx="2">
+            <a:schemeClr val="accent1"/>
+          </a:effectRef>
+          <a:fontRef idx="minor">
+            <a:schemeClr val="lt1"/>
+          </a:fontRef>
+        </p:style>
+        <p:txBody>
+          <a:bodyPr rtlCol="0" anchor="ctr"/>
+          <a:lstStyle/>
+          <a:p>
+            <a:pPr algn="ctr"/>
+          </a:p>
+        </p:txBody>
+      </p:sp>
+      <p:sp>
+        <p:nvSpPr>
+          <p:cNvPr id="18" name="Rectangle 17"/>
+          <p:cNvSpPr/>
+          <p:nvPr/>
+        </p:nvSpPr>
+        <p:spPr>
+          <a:xfrm>
+            <a:off x="548640" y="3310128"/>
+            <a:ext cx="54864" cy="777240"/>
+          </a:xfrm>
+          <a:prstGeom prst="rect">
+            <a:avLst/>
+          </a:prstGeom>
+          <a:solidFill>
+            <a:srgbClr val="F5A623"/>
+          </a:solidFill>
+          <a:ln>
+            <a:noFill/>
+          </a:ln>
+          <a:effectLst/>
+        </p:spPr>
+        <p:style>
+          <a:lnRef idx="1">
+            <a:schemeClr val="accent1"/>
+          </a:lnRef>
+          <a:fillRef idx="3">
+            <a:schemeClr val="accent1"/>
+          </a:fillRef>
+          <a:effectRef idx="2">
+            <a:schemeClr val="accent1"/>
+          </a:effectRef>
+          <a:fontRef idx="minor">
+            <a:schemeClr val="lt1"/>
+          </a:fontRef>
+        </p:style>
+        <p:txBody>
+          <a:bodyPr rtlCol="0" anchor="ctr"/>
+          <a:lstStyle/>
+          <a:p>
+            <a:pPr algn="ctr"/>
+          </a:p>
+        </p:txBody>
+      </p:sp>
+      <p:sp>
+        <p:nvSpPr>
+          <p:cNvPr id="19" name="TextBox 18"/>
+          <p:cNvSpPr txBox="1"/>
+          <p:nvPr/>
+        </p:nvSpPr>
+        <p:spPr>
+          <a:xfrm>
+            <a:off x="713232" y="3383280"/>
+            <a:ext cx="4892040" cy="630936"/>
+          </a:xfrm>
+          <a:prstGeom prst="rect">
+            <a:avLst/>
+          </a:prstGeom>
+          <a:noFill/>
+        </p:spPr>
+        <p:txBody>
+          <a:bodyPr wrap="square" anchor="ctr">
+            <a:spAutoFit/>
+          </a:bodyPr>
+          <a:lstStyle/>
+          <a:p>
+            <a:pPr algn="l"/>
+            <a:r>
+              <a:rPr sz="1600" b="0">
+                <a:solidFill>
+                  <a:srgbClr val="FFFFFF"/>
+                </a:solidFill>
+                <a:latin typeface="Calibri"/>
+              </a:rPr>
+              <a:t>{{FILA_2_VIDA_REAL}}</a:t>
+            </a:r>
+          </a:p>
+        </p:txBody>
+      </p:sp>
+      <p:sp>
+        <p:nvSpPr>
+          <p:cNvPr id="20" name="TextBox 19"/>
+          <p:cNvSpPr txBox="1"/>
+          <p:nvPr/>
+        </p:nvSpPr>
+        <p:spPr>
+          <a:xfrm>
+            <a:off x="5715000" y="3310128"/>
+            <a:ext cx="457200" cy="777240"/>
+          </a:xfrm>
+          <a:prstGeom prst="rect">
+            <a:avLst/>
+          </a:prstGeom>
+          <a:noFill/>
+        </p:spPr>
+        <p:txBody>
+          <a:bodyPr wrap="square" anchor="ctr">
+            <a:spAutoFit/>
+          </a:bodyPr>
+          <a:lstStyle/>
+          <a:p>
+            <a:pPr algn="ctr"/>
+            <a:r>
+              <a:rPr sz="2000" b="1">
+                <a:solidFill>
+                  <a:srgbClr val="0F9B8E"/>
+                </a:solidFill>
+                <a:latin typeface="Calibri"/>
+              </a:rPr>
+              <a:t>↔</a:t>
+            </a:r>
+          </a:p>
+        </p:txBody>
+      </p:sp>
+      <p:sp>
+        <p:nvSpPr>
+          <p:cNvPr id="21" name="Rectangle 20"/>
+          <p:cNvSpPr/>
+          <p:nvPr/>
+        </p:nvSpPr>
+        <p:spPr>
+          <a:xfrm>
+            <a:off x="6172200" y="3310128"/>
+            <a:ext cx="5470855" cy="777240"/>
+          </a:xfrm>
+          <a:prstGeom prst="rect">
+            <a:avLst/>
+          </a:prstGeom>
+          <a:solidFill>
+            <a:srgbClr val="0D1117"/>
+          </a:solidFill>
+          <a:ln>
+            <a:noFill/>
+          </a:ln>
+          <a:effectLst/>
+        </p:spPr>
+        <p:style>
+          <a:lnRef idx="1">
+            <a:schemeClr val="accent1"/>
+          </a:lnRef>
+          <a:fillRef idx="3">
+            <a:schemeClr val="accent1"/>
+          </a:fillRef>
+          <a:effectRef idx="2">
+            <a:schemeClr val="accent1"/>
+          </a:effectRef>
+          <a:fontRef idx="minor">
+            <a:schemeClr val="lt1"/>
+          </a:fontRef>
+        </p:style>
+        <p:txBody>
+          <a:bodyPr rtlCol="0" anchor="ctr"/>
+          <a:lstStyle/>
+          <a:p>
+            <a:pPr algn="ctr"/>
+          </a:p>
+        </p:txBody>
+      </p:sp>
+      <p:sp>
+        <p:nvSpPr>
+          <p:cNvPr id="22" name="Rectangle 21"/>
+          <p:cNvSpPr/>
+          <p:nvPr/>
+        </p:nvSpPr>
+        <p:spPr>
+          <a:xfrm>
+            <a:off x="6172200" y="3310128"/>
+            <a:ext cx="54864" cy="777240"/>
+          </a:xfrm>
+          <a:prstGeom prst="rect">
+            <a:avLst/>
+          </a:prstGeom>
+          <a:solidFill>
+            <a:srgbClr val="0F9B8E"/>
+          </a:solidFill>
+          <a:ln>
+            <a:noFill/>
+          </a:ln>
+          <a:effectLst/>
+        </p:spPr>
+        <p:style>
+          <a:lnRef idx="1">
+            <a:schemeClr val="accent1"/>
+          </a:lnRef>
+          <a:fillRef idx="3">
+            <a:schemeClr val="accent1"/>
+          </a:fillRef>
+          <a:effectRef idx="2">
+            <a:schemeClr val="accent1"/>
+          </a:effectRef>
+          <a:fontRef idx="minor">
+            <a:schemeClr val="lt1"/>
+          </a:fontRef>
+        </p:style>
+        <p:txBody>
+          <a:bodyPr rtlCol="0" anchor="ctr"/>
+          <a:lstStyle/>
+          <a:p>
+            <a:pPr algn="ctr"/>
+          </a:p>
+        </p:txBody>
+      </p:sp>
+      <p:sp>
+        <p:nvSpPr>
+          <p:cNvPr id="23" name="TextBox 22"/>
+          <p:cNvSpPr txBox="1"/>
+          <p:nvPr/>
+        </p:nvSpPr>
+        <p:spPr>
+          <a:xfrm>
+            <a:off x="6336792" y="3383280"/>
+            <a:ext cx="5196535" cy="630936"/>
+          </a:xfrm>
+          <a:prstGeom prst="rect">
+            <a:avLst/>
+          </a:prstGeom>
+          <a:noFill/>
+        </p:spPr>
+        <p:txBody>
+          <a:bodyPr wrap="square" anchor="ctr">
+            <a:spAutoFit/>
+          </a:bodyPr>
+          <a:lstStyle/>
+          <a:p>
+            <a:pPr algn="l"/>
+            <a:r>
+              <a:rPr sz="1600" b="0">
+                <a:solidFill>
+                  <a:srgbClr val="4ADFCB"/>
+                </a:solidFill>
+                <a:latin typeface="Consolas"/>
+              </a:rPr>
+              <a:t>{{FILA_2_PYTHON}}</a:t>
+            </a:r>
+          </a:p>
+        </p:txBody>
+      </p:sp>
+      <p:sp>
+        <p:nvSpPr>
+          <p:cNvPr id="24" name="Rectangle 23"/>
+          <p:cNvSpPr/>
+          <p:nvPr/>
+        </p:nvSpPr>
+        <p:spPr>
+          <a:xfrm>
+            <a:off x="548640" y="4197096"/>
+            <a:ext cx="5166360" cy="777240"/>
+          </a:xfrm>
+          <a:prstGeom prst="rect">
+            <a:avLst/>
+          </a:prstGeom>
+          <a:solidFill>
+            <a:srgbClr val="16213E"/>
+          </a:solidFill>
+          <a:ln>
+            <a:noFill/>
+          </a:ln>
+          <a:effectLst/>
+        </p:spPr>
+        <p:style>
+          <a:lnRef idx="1">
+            <a:schemeClr val="accent1"/>
+          </a:lnRef>
+          <a:fillRef idx="3">
+            <a:schemeClr val="accent1"/>
+          </a:fillRef>
+          <a:effectRef idx="2">
+            <a:schemeClr val="accent1"/>
+          </a:effectRef>
+          <a:fontRef idx="minor">
+            <a:schemeClr val="lt1"/>
+          </a:fontRef>
+        </p:style>
+        <p:txBody>
+          <a:bodyPr rtlCol="0" anchor="ctr"/>
+          <a:lstStyle/>
+          <a:p>
+            <a:pPr algn="ctr"/>
+          </a:p>
+        </p:txBody>
+      </p:sp>
+      <p:sp>
+        <p:nvSpPr>
+          <p:cNvPr id="25" name="Rectangle 24"/>
+          <p:cNvSpPr/>
+          <p:nvPr/>
+        </p:nvSpPr>
+        <p:spPr>
+          <a:xfrm>
+            <a:off x="548640" y="4197096"/>
+            <a:ext cx="54864" cy="777240"/>
+          </a:xfrm>
+          <a:prstGeom prst="rect">
+            <a:avLst/>
+          </a:prstGeom>
+          <a:solidFill>
+            <a:srgbClr val="F5A623"/>
+          </a:solidFill>
+          <a:ln>
+            <a:noFill/>
+          </a:ln>
+          <a:effectLst/>
+        </p:spPr>
+        <p:style>
+          <a:lnRef idx="1">
+            <a:schemeClr val="accent1"/>
+          </a:lnRef>
+          <a:fillRef idx="3">
+            <a:schemeClr val="accent1"/>
+          </a:fillRef>
+          <a:effectRef idx="2">
+            <a:schemeClr val="accent1"/>
+          </a:effectRef>
+          <a:fontRef idx="minor">
+            <a:schemeClr val="lt1"/>
+          </a:fontRef>
+        </p:style>
+        <p:txBody>
+          <a:bodyPr rtlCol="0" anchor="ctr"/>
+          <a:lstStyle/>
+          <a:p>
+            <a:pPr algn="ctr"/>
+          </a:p>
+        </p:txBody>
+      </p:sp>
+      <p:sp>
+        <p:nvSpPr>
+          <p:cNvPr id="26" name="TextBox 25"/>
+          <p:cNvSpPr txBox="1"/>
+          <p:nvPr/>
+        </p:nvSpPr>
+        <p:spPr>
+          <a:xfrm>
+            <a:off x="713232" y="4270248"/>
+            <a:ext cx="4892040" cy="630936"/>
+          </a:xfrm>
+          <a:prstGeom prst="rect">
+            <a:avLst/>
+          </a:prstGeom>
+          <a:noFill/>
+        </p:spPr>
+        <p:txBody>
+          <a:bodyPr wrap="square" anchor="ctr">
+            <a:spAutoFit/>
+          </a:bodyPr>
+          <a:lstStyle/>
+          <a:p>
+            <a:pPr algn="l"/>
+            <a:r>
+              <a:rPr sz="1600" b="0">
+                <a:solidFill>
+                  <a:srgbClr val="FFFFFF"/>
+                </a:solidFill>
+                <a:latin typeface="Calibri"/>
+              </a:rPr>
+              <a:t>{{FILA_3_VIDA_REAL}}</a:t>
+            </a:r>
+          </a:p>
+        </p:txBody>
+      </p:sp>
+      <p:sp>
+        <p:nvSpPr>
+          <p:cNvPr id="27" name="TextBox 26"/>
+          <p:cNvSpPr txBox="1"/>
+          <p:nvPr/>
+        </p:nvSpPr>
+        <p:spPr>
+          <a:xfrm>
+            <a:off x="5715000" y="4197096"/>
+            <a:ext cx="457200" cy="777240"/>
+          </a:xfrm>
+          <a:prstGeom prst="rect">
+            <a:avLst/>
+          </a:prstGeom>
+          <a:noFill/>
+        </p:spPr>
+        <p:txBody>
+          <a:bodyPr wrap="square" anchor="ctr">
+            <a:spAutoFit/>
+          </a:bodyPr>
+          <a:lstStyle/>
+          <a:p>
+            <a:pPr algn="ctr"/>
+            <a:r>
+              <a:rPr sz="2000" b="1">
+                <a:solidFill>
+                  <a:srgbClr val="0F9B8E"/>
+                </a:solidFill>
+                <a:latin typeface="Calibri"/>
+              </a:rPr>
+              <a:t>↔</a:t>
+            </a:r>
+          </a:p>
+        </p:txBody>
+      </p:sp>
+      <p:sp>
+        <p:nvSpPr>
+          <p:cNvPr id="28" name="Rectangle 27"/>
+          <p:cNvSpPr/>
+          <p:nvPr/>
+        </p:nvSpPr>
+        <p:spPr>
+          <a:xfrm>
+            <a:off x="6172200" y="4197096"/>
+            <a:ext cx="5470855" cy="777240"/>
+          </a:xfrm>
+          <a:prstGeom prst="rect">
+            <a:avLst/>
+          </a:prstGeom>
+          <a:solidFill>
+            <a:srgbClr val="0D1117"/>
+          </a:solidFill>
+          <a:ln>
+            <a:noFill/>
+          </a:ln>
+          <a:effectLst/>
+        </p:spPr>
+        <p:style>
+          <a:lnRef idx="1">
+            <a:schemeClr val="accent1"/>
+          </a:lnRef>
+          <a:fillRef idx="3">
+            <a:schemeClr val="accent1"/>
+          </a:fillRef>
+          <a:effectRef idx="2">
+            <a:schemeClr val="accent1"/>
+          </a:effectRef>
+          <a:fontRef idx="minor">
+            <a:schemeClr val="lt1"/>
+          </a:fontRef>
+        </p:style>
+        <p:txBody>
+          <a:bodyPr rtlCol="0" anchor="ctr"/>
+          <a:lstStyle/>
+          <a:p>
+            <a:pPr algn="ctr"/>
+          </a:p>
+        </p:txBody>
+      </p:sp>
+      <p:sp>
+        <p:nvSpPr>
+          <p:cNvPr id="29" name="Rectangle 28"/>
+          <p:cNvSpPr/>
+          <p:nvPr/>
+        </p:nvSpPr>
+        <p:spPr>
+          <a:xfrm>
+            <a:off x="6172200" y="4197096"/>
+            <a:ext cx="54864" cy="777240"/>
+          </a:xfrm>
+          <a:prstGeom prst="rect">
+            <a:avLst/>
+          </a:prstGeom>
+          <a:solidFill>
+            <a:srgbClr val="0F9B8E"/>
+          </a:solidFill>
+          <a:ln>
+            <a:noFill/>
+          </a:ln>
+          <a:effectLst/>
+        </p:spPr>
+        <p:style>
+          <a:lnRef idx="1">
+            <a:schemeClr val="accent1"/>
+          </a:lnRef>
+          <a:fillRef idx="3">
+            <a:schemeClr val="accent1"/>
+          </a:fillRef>
+          <a:effectRef idx="2">
+            <a:schemeClr val="accent1"/>
+          </a:effectRef>
+          <a:fontRef idx="minor">
+            <a:schemeClr val="lt1"/>
+          </a:fontRef>
+        </p:style>
+        <p:txBody>
+          <a:bodyPr rtlCol="0" anchor="ctr"/>
+          <a:lstStyle/>
+          <a:p>
+            <a:pPr algn="ctr"/>
+          </a:p>
+        </p:txBody>
+      </p:sp>
+      <p:sp>
+        <p:nvSpPr>
+          <p:cNvPr id="30" name="TextBox 29"/>
+          <p:cNvSpPr txBox="1"/>
+          <p:nvPr/>
+        </p:nvSpPr>
+        <p:spPr>
+          <a:xfrm>
+            <a:off x="6336792" y="4270248"/>
+            <a:ext cx="5196535" cy="630936"/>
+          </a:xfrm>
+          <a:prstGeom prst="rect">
+            <a:avLst/>
+          </a:prstGeom>
+          <a:noFill/>
+        </p:spPr>
+        <p:txBody>
+          <a:bodyPr wrap="square" anchor="ctr">
+            <a:spAutoFit/>
+          </a:bodyPr>
+          <a:lstStyle/>
+          <a:p>
+            <a:pPr algn="l"/>
+            <a:r>
+              <a:rPr sz="1600" b="0">
+                <a:solidFill>
+                  <a:srgbClr val="4ADFCB"/>
+                </a:solidFill>
+                <a:latin typeface="Consolas"/>
+              </a:rPr>
+              <a:t>{{FILA_3_PYTHON}}</a:t>
+            </a:r>
+          </a:p>
+        </p:txBody>
+      </p:sp>
+      <p:sp>
+        <p:nvSpPr>
+          <p:cNvPr id="31" name="Rectangle 30"/>
+          <p:cNvSpPr/>
+          <p:nvPr/>
+        </p:nvSpPr>
+        <p:spPr>
+          <a:xfrm>
+            <a:off x="548640" y="5084064"/>
+            <a:ext cx="5166360" cy="777240"/>
+          </a:xfrm>
+          <a:prstGeom prst="rect">
+            <a:avLst/>
+          </a:prstGeom>
+          <a:solidFill>
+            <a:srgbClr val="16213E"/>
+          </a:solidFill>
+          <a:ln>
+            <a:noFill/>
+          </a:ln>
+          <a:effectLst/>
+        </p:spPr>
+        <p:style>
+          <a:lnRef idx="1">
+            <a:schemeClr val="accent1"/>
+          </a:lnRef>
+          <a:fillRef idx="3">
+            <a:schemeClr val="accent1"/>
+          </a:fillRef>
+          <a:effectRef idx="2">
+            <a:schemeClr val="accent1"/>
+          </a:effectRef>
+          <a:fontRef idx="minor">
+            <a:schemeClr val="lt1"/>
+          </a:fontRef>
+        </p:style>
+        <p:txBody>
+          <a:bodyPr rtlCol="0" anchor="ctr"/>
+          <a:lstStyle/>
+          <a:p>
+            <a:pPr algn="ctr"/>
+          </a:p>
+        </p:txBody>
+      </p:sp>
+      <p:sp>
+        <p:nvSpPr>
+          <p:cNvPr id="32" name="Rectangle 31"/>
+          <p:cNvSpPr/>
+          <p:nvPr/>
+        </p:nvSpPr>
+        <p:spPr>
+          <a:xfrm>
+            <a:off x="548640" y="5084064"/>
+            <a:ext cx="54864" cy="777240"/>
+          </a:xfrm>
+          <a:prstGeom prst="rect">
+            <a:avLst/>
+          </a:prstGeom>
+          <a:solidFill>
+            <a:srgbClr val="F5A623"/>
+          </a:solidFill>
+          <a:ln>
+            <a:noFill/>
+          </a:ln>
+          <a:effectLst/>
+        </p:spPr>
+        <p:style>
+          <a:lnRef idx="1">
+            <a:schemeClr val="accent1"/>
+          </a:lnRef>
+          <a:fillRef idx="3">
+            <a:schemeClr val="accent1"/>
+          </a:fillRef>
+          <a:effectRef idx="2">
+            <a:schemeClr val="accent1"/>
+          </a:effectRef>
+          <a:fontRef idx="minor">
+            <a:schemeClr val="lt1"/>
+          </a:fontRef>
+        </p:style>
+        <p:txBody>
+          <a:bodyPr rtlCol="0" anchor="ctr"/>
+          <a:lstStyle/>
+          <a:p>
+            <a:pPr algn="ctr"/>
+          </a:p>
+        </p:txBody>
+      </p:sp>
+      <p:sp>
+        <p:nvSpPr>
+          <p:cNvPr id="33" name="TextBox 32"/>
+          <p:cNvSpPr txBox="1"/>
+          <p:nvPr/>
+        </p:nvSpPr>
+        <p:spPr>
+          <a:xfrm>
+            <a:off x="713232" y="5157216"/>
+            <a:ext cx="4892040" cy="630936"/>
+          </a:xfrm>
+          <a:prstGeom prst="rect">
+            <a:avLst/>
+          </a:prstGeom>
+          <a:noFill/>
+        </p:spPr>
+        <p:txBody>
+          <a:bodyPr wrap="square" anchor="ctr">
+            <a:spAutoFit/>
+          </a:bodyPr>
+          <a:lstStyle/>
+          <a:p>
+            <a:pPr algn="l"/>
+            <a:r>
+              <a:rPr sz="1600" b="0">
+                <a:solidFill>
+                  <a:srgbClr val="FFFFFF"/>
+                </a:solidFill>
+                <a:latin typeface="Calibri"/>
+              </a:rPr>
+              <a:t>{{FILA_4_VIDA_REAL}}</a:t>
+            </a:r>
+          </a:p>
+        </p:txBody>
+      </p:sp>
+      <p:sp>
+        <p:nvSpPr>
+          <p:cNvPr id="34" name="TextBox 33"/>
+          <p:cNvSpPr txBox="1"/>
+          <p:nvPr/>
+        </p:nvSpPr>
+        <p:spPr>
+          <a:xfrm>
+            <a:off x="5715000" y="5084064"/>
+            <a:ext cx="457200" cy="777240"/>
+          </a:xfrm>
+          <a:prstGeom prst="rect">
+            <a:avLst/>
+          </a:prstGeom>
+          <a:noFill/>
+        </p:spPr>
+        <p:txBody>
+          <a:bodyPr wrap="square" anchor="ctr">
+            <a:spAutoFit/>
+          </a:bodyPr>
+          <a:lstStyle/>
+          <a:p>
+            <a:pPr algn="ctr"/>
+            <a:r>
+              <a:rPr sz="2000" b="1">
+                <a:solidFill>
+                  <a:srgbClr val="0F9B8E"/>
+                </a:solidFill>
+                <a:latin typeface="Calibri"/>
+              </a:rPr>
+              <a:t>↔</a:t>
+            </a:r>
+          </a:p>
+        </p:txBody>
+      </p:sp>
+      <p:sp>
+        <p:nvSpPr>
+          <p:cNvPr id="35" name="Rectangle 34"/>
+          <p:cNvSpPr/>
+          <p:nvPr/>
+        </p:nvSpPr>
+        <p:spPr>
+          <a:xfrm>
+            <a:off x="6172200" y="5084064"/>
+            <a:ext cx="5470855" cy="777240"/>
+          </a:xfrm>
+          <a:prstGeom prst="rect">
+            <a:avLst/>
+          </a:prstGeom>
+          <a:solidFill>
+            <a:srgbClr val="0D1117"/>
+          </a:solidFill>
+          <a:ln>
+            <a:noFill/>
+          </a:ln>
+          <a:effectLst/>
+        </p:spPr>
+        <p:style>
+          <a:lnRef idx="1">
+            <a:schemeClr val="accent1"/>
+          </a:lnRef>
+          <a:fillRef idx="3">
+            <a:schemeClr val="accent1"/>
+          </a:fillRef>
+          <a:effectRef idx="2">
+            <a:schemeClr val="accent1"/>
+          </a:effectRef>
+          <a:fontRef idx="minor">
+            <a:schemeClr val="lt1"/>
+          </a:fontRef>
+        </p:style>
+        <p:txBody>
+          <a:bodyPr rtlCol="0" anchor="ctr"/>
+          <a:lstStyle/>
+          <a:p>
+            <a:pPr algn="ctr"/>
+          </a:p>
+        </p:txBody>
+      </p:sp>
+      <p:sp>
+        <p:nvSpPr>
+          <p:cNvPr id="36" name="Rectangle 35"/>
+          <p:cNvSpPr/>
+          <p:nvPr/>
+        </p:nvSpPr>
+        <p:spPr>
+          <a:xfrm>
+            <a:off x="6172200" y="5084064"/>
+            <a:ext cx="54864" cy="777240"/>
+          </a:xfrm>
+          <a:prstGeom prst="rect">
+            <a:avLst/>
+          </a:prstGeom>
+          <a:solidFill>
+            <a:srgbClr val="0F9B8E"/>
+          </a:solidFill>
+          <a:ln>
+            <a:noFill/>
+          </a:ln>
+          <a:effectLst/>
+        </p:spPr>
+        <p:style>
+          <a:lnRef idx="1">
+            <a:schemeClr val="accent1"/>
+          </a:lnRef>
+          <a:fillRef idx="3">
+            <a:schemeClr val="accent1"/>
+          </a:fillRef>
+          <a:effectRef idx="2">
+            <a:schemeClr val="accent1"/>
+          </a:effectRef>
+          <a:fontRef idx="minor">
+            <a:schemeClr val="lt1"/>
+          </a:fontRef>
+        </p:style>
+        <p:txBody>
+          <a:bodyPr rtlCol="0" anchor="ctr"/>
+          <a:lstStyle/>
+          <a:p>
+            <a:pPr algn="ctr"/>
+          </a:p>
+        </p:txBody>
+      </p:sp>
+      <p:sp>
+        <p:nvSpPr>
+          <p:cNvPr id="37" name="TextBox 36"/>
+          <p:cNvSpPr txBox="1"/>
+          <p:nvPr/>
+        </p:nvSpPr>
+        <p:spPr>
+          <a:xfrm>
+            <a:off x="6336792" y="5157216"/>
+            <a:ext cx="5196535" cy="630936"/>
+          </a:xfrm>
+          <a:prstGeom prst="rect">
+            <a:avLst/>
+          </a:prstGeom>
+          <a:noFill/>
+        </p:spPr>
+        <p:txBody>
+          <a:bodyPr wrap="square" anchor="ctr">
+            <a:spAutoFit/>
+          </a:bodyPr>
+          <a:lstStyle/>
+          <a:p>
+            <a:pPr algn="l"/>
+            <a:r>
+              <a:rPr sz="1600" b="0">
+                <a:solidFill>
+                  <a:srgbClr val="4ADFCB"/>
+                </a:solidFill>
+                <a:latin typeface="Consolas"/>
+              </a:rPr>
+              <a:t>{{FILA_4_PYTHON}}</a:t>
+            </a:r>
+          </a:p>
+        </p:txBody>
+      </p:sp>
+    </p:spTree>
+  </p:cSld>
+  <p:clrMapOvr>
+    <a:masterClrMapping/>
+  </p:clrMapOvr>
+</p:sld>
+</file>
+
+<file path=ppt/slides/slide13.xml><?xml version="1.0" encoding="utf-8"?>
+<p:sld xmlns:a="http://schemas.openxmlformats.org/drawingml/2006/main" xmlns:p="http://schemas.openxmlformats.org/presentationml/2006/main" xmlns:r="http://schemas.openxmlformats.org/officeDocument/2006/relationships">
+  <p:cSld>
+    <p:spTree>
+      <p:nvGrpSpPr>
+        <p:cNvPr id="1" name=""/>
+        <p:cNvGrpSpPr/>
+        <p:nvPr/>
+      </p:nvGrpSpPr>
+      <p:grpSpPr/>
+      <p:sp>
+        <p:nvSpPr>
+          <p:cNvPr id="2" name="Rectangle 1"/>
+          <p:cNvSpPr/>
+          <p:nvPr/>
+        </p:nvSpPr>
+        <p:spPr>
+          <a:xfrm>
+            <a:off x="0" y="0"/>
+            <a:ext cx="12191695" cy="6858000"/>
+          </a:xfrm>
+          <a:prstGeom prst="rect">
+            <a:avLst/>
+          </a:prstGeom>
+          <a:solidFill>
+            <a:srgbClr val="1A1A2E"/>
+          </a:solidFill>
+          <a:ln>
+            <a:noFill/>
+          </a:ln>
+          <a:effectLst/>
+        </p:spPr>
+        <p:style>
+          <a:lnRef idx="1">
+            <a:schemeClr val="accent1"/>
+          </a:lnRef>
+          <a:fillRef idx="3">
+            <a:schemeClr val="accent1"/>
+          </a:fillRef>
+          <a:effectRef idx="2">
+            <a:schemeClr val="accent1"/>
+          </a:effectRef>
+          <a:fontRef idx="minor">
+            <a:schemeClr val="lt1"/>
+          </a:fontRef>
+        </p:style>
+        <p:txBody>
+          <a:bodyPr rtlCol="0" anchor="ctr"/>
+          <a:lstStyle/>
+          <a:p>
+            <a:pPr algn="ctr"/>
+          </a:p>
+        </p:txBody>
+      </p:sp>
+      <p:sp>
+        <p:nvSpPr>
+          <p:cNvPr id="3" name="Rectangle 2"/>
+          <p:cNvSpPr/>
+          <p:nvPr/>
+        </p:nvSpPr>
+        <p:spPr>
+          <a:xfrm>
+            <a:off x="0" y="0"/>
+            <a:ext cx="12191695" cy="502920"/>
+          </a:xfrm>
+          <a:prstGeom prst="rect">
+            <a:avLst/>
+          </a:prstGeom>
+          <a:solidFill>
+            <a:srgbClr val="0F162A"/>
+          </a:solidFill>
+          <a:ln>
+            <a:noFill/>
+          </a:ln>
+          <a:effectLst/>
+        </p:spPr>
+        <p:style>
+          <a:lnRef idx="1">
+            <a:schemeClr val="accent1"/>
+          </a:lnRef>
+          <a:fillRef idx="3">
+            <a:schemeClr val="accent1"/>
+          </a:fillRef>
+          <a:effectRef idx="2">
+            <a:schemeClr val="accent1"/>
+          </a:effectRef>
+          <a:fontRef idx="minor">
+            <a:schemeClr val="lt1"/>
+          </a:fontRef>
+        </p:style>
+        <p:txBody>
+          <a:bodyPr rtlCol="0" anchor="ctr"/>
+          <a:lstStyle/>
+          <a:p>
+            <a:pPr algn="ctr"/>
+          </a:p>
+        </p:txBody>
+      </p:sp>
+      <p:sp>
+        <p:nvSpPr>
+          <p:cNvPr id="4" name="TextBox 3"/>
+          <p:cNvSpPr txBox="1"/>
+          <p:nvPr/>
+        </p:nvSpPr>
+        <p:spPr>
+          <a:xfrm>
+            <a:off x="411479" y="118872"/>
+            <a:ext cx="5486400" cy="320040"/>
+          </a:xfrm>
+          <a:prstGeom prst="rect">
+            <a:avLst/>
+          </a:prstGeom>
+          <a:noFill/>
+        </p:spPr>
+        <p:txBody>
+          <a:bodyPr wrap="square" anchor="ctr">
+            <a:spAutoFit/>
+          </a:bodyPr>
+          <a:lstStyle/>
+          <a:p>
+            <a:pPr algn="l"/>
+            <a:r>
+              <a:rPr sz="1200" b="0">
+                <a:solidFill>
+                  <a:srgbClr val="94A3B8"/>
+                </a:solidFill>
+                <a:latin typeface="Consolas"/>
+              </a:rPr>
+              <a:t>🐍 Python · Clase {{NUMERO_CLASE}}</a:t>
+            </a:r>
+          </a:p>
+        </p:txBody>
+      </p:sp>
+      <p:sp>
+        <p:nvSpPr>
+          <p:cNvPr id="5" name="TextBox 4"/>
+          <p:cNvSpPr txBox="1"/>
+          <p:nvPr/>
+        </p:nvSpPr>
+        <p:spPr>
+          <a:xfrm>
+            <a:off x="8534095" y="118872"/>
+            <a:ext cx="3200400" cy="320040"/>
+          </a:xfrm>
+          <a:prstGeom prst="rect">
+            <a:avLst/>
+          </a:prstGeom>
+          <a:noFill/>
+        </p:spPr>
+        <p:txBody>
+          <a:bodyPr wrap="square" anchor="ctr">
+            <a:spAutoFit/>
+          </a:bodyPr>
+          <a:lstStyle/>
+          <a:p>
+            <a:pPr algn="r"/>
+            <a:r>
+              <a:rPr sz="1200" b="1">
+                <a:solidFill>
+                  <a:srgbClr val="0F9B8E"/>
+                </a:solidFill>
+                <a:latin typeface="Consolas"/>
+              </a:rPr>
+              <a:t>{{SECCION}}</a:t>
+            </a:r>
+          </a:p>
+        </p:txBody>
+      </p:sp>
+      <p:sp>
+        <p:nvSpPr>
+          <p:cNvPr id="6" name="TextBox 5"/>
+          <p:cNvSpPr txBox="1"/>
+          <p:nvPr/>
+        </p:nvSpPr>
+        <p:spPr>
+          <a:xfrm>
+            <a:off x="548640" y="868680"/>
+            <a:ext cx="11094415" cy="685800"/>
+          </a:xfrm>
+          <a:prstGeom prst="rect">
+            <a:avLst/>
+          </a:prstGeom>
+          <a:noFill/>
+        </p:spPr>
+        <p:txBody>
+          <a:bodyPr wrap="square" anchor="t">
+            <a:spAutoFit/>
+          </a:bodyPr>
+          <a:lstStyle/>
+          <a:p>
+            <a:pPr algn="l"/>
+            <a:r>
+              <a:rPr sz="3200" b="1">
+                <a:solidFill>
+                  <a:srgbClr val="FFFFFF"/>
+                </a:solidFill>
+                <a:latin typeface="Calibri"/>
+              </a:rPr>
+              <a:t>{{TITULO_SLIDE}}</a:t>
+            </a:r>
+          </a:p>
+        </p:txBody>
+      </p:sp>
+      <p:sp>
+        <p:nvSpPr>
+          <p:cNvPr id="7" name="TextBox 6"/>
+          <p:cNvSpPr txBox="1"/>
+          <p:nvPr/>
+        </p:nvSpPr>
+        <p:spPr>
+          <a:xfrm>
+            <a:off x="548640" y="1508760"/>
+            <a:ext cx="11094415" cy="365760"/>
+          </a:xfrm>
+          <a:prstGeom prst="rect">
+            <a:avLst/>
+          </a:prstGeom>
+          <a:noFill/>
+        </p:spPr>
+        <p:txBody>
+          <a:bodyPr wrap="square" anchor="t">
+            <a:spAutoFit/>
+          </a:bodyPr>
+          <a:lstStyle/>
+          <a:p>
+            <a:pPr algn="l"/>
+            <a:r>
+              <a:rPr sz="2200" b="0">
+                <a:solidFill>
+                  <a:srgbClr val="FFFFFF"/>
+                </a:solidFill>
+                <a:latin typeface="Calibri"/>
+              </a:rPr>
+              <a:t>{{SUBTITULO_SLIDE}}</a:t>
+            </a:r>
+          </a:p>
+        </p:txBody>
+      </p:sp>
+      <p:sp>
+        <p:nvSpPr>
+          <p:cNvPr id="8" name="TextBox 7"/>
+          <p:cNvSpPr txBox="1"/>
+          <p:nvPr/>
+        </p:nvSpPr>
+        <p:spPr>
+          <a:xfrm>
+            <a:off x="548640" y="2011680"/>
+            <a:ext cx="5410047" cy="365760"/>
+          </a:xfrm>
+          <a:prstGeom prst="rect">
+            <a:avLst/>
+          </a:prstGeom>
+          <a:noFill/>
+        </p:spPr>
+        <p:txBody>
+          <a:bodyPr wrap="square" anchor="t">
+            <a:spAutoFit/>
+          </a:bodyPr>
+          <a:lstStyle/>
+          <a:p>
+            <a:pPr algn="l"/>
+            <a:r>
+              <a:rPr sz="1800" b="1">
+                <a:solidFill>
+                  <a:srgbClr val="FC3535"/>
+                </a:solidFill>
+                <a:latin typeface="Calibri"/>
+              </a:rPr>
+              <a:t>{{ANTES_LABEL}}</a:t>
+            </a:r>
+          </a:p>
+        </p:txBody>
+      </p:sp>
+      <p:sp>
+        <p:nvSpPr>
+          <p:cNvPr id="9" name="Rectangle 8"/>
+          <p:cNvSpPr/>
+          <p:nvPr/>
+        </p:nvSpPr>
+        <p:spPr>
+          <a:xfrm>
+            <a:off x="548640" y="2423160"/>
+            <a:ext cx="5410047" cy="3108960"/>
+          </a:xfrm>
+          <a:prstGeom prst="rect">
+            <a:avLst/>
+          </a:prstGeom>
+          <a:solidFill>
+            <a:srgbClr val="0D1117"/>
+          </a:solidFill>
+          <a:ln>
+            <a:noFill/>
+          </a:ln>
+          <a:effectLst/>
+        </p:spPr>
+        <p:style>
+          <a:lnRef idx="1">
+            <a:schemeClr val="accent1"/>
+          </a:lnRef>
+          <a:fillRef idx="3">
+            <a:schemeClr val="accent1"/>
+          </a:fillRef>
+          <a:effectRef idx="2">
+            <a:schemeClr val="accent1"/>
+          </a:effectRef>
+          <a:fontRef idx="minor">
+            <a:schemeClr val="lt1"/>
+          </a:fontRef>
+        </p:style>
+        <p:txBody>
+          <a:bodyPr rtlCol="0" anchor="ctr"/>
+          <a:lstStyle/>
+          <a:p>
+            <a:pPr algn="ctr"/>
+          </a:p>
+        </p:txBody>
+      </p:sp>
+      <p:sp>
+        <p:nvSpPr>
+          <p:cNvPr id="10" name="Rectangle 9"/>
+          <p:cNvSpPr/>
+          <p:nvPr/>
+        </p:nvSpPr>
+        <p:spPr>
+          <a:xfrm>
+            <a:off x="548640" y="2423160"/>
+            <a:ext cx="5410047" cy="73152"/>
+          </a:xfrm>
+          <a:prstGeom prst="rect">
+            <a:avLst/>
+          </a:prstGeom>
+          <a:solidFill>
+            <a:srgbClr val="FC3535"/>
+          </a:solidFill>
+          <a:ln>
+            <a:noFill/>
+          </a:ln>
+          <a:effectLst/>
+        </p:spPr>
+        <p:style>
+          <a:lnRef idx="1">
+            <a:schemeClr val="accent1"/>
+          </a:lnRef>
+          <a:fillRef idx="3">
+            <a:schemeClr val="accent1"/>
+          </a:fillRef>
+          <a:effectRef idx="2">
+            <a:schemeClr val="accent1"/>
+          </a:effectRef>
+          <a:fontRef idx="minor">
+            <a:schemeClr val="lt1"/>
+          </a:fontRef>
+        </p:style>
+        <p:txBody>
+          <a:bodyPr rtlCol="0" anchor="ctr"/>
+          <a:lstStyle/>
+          <a:p>
+            <a:pPr algn="ctr"/>
+          </a:p>
+        </p:txBody>
+      </p:sp>
+      <p:sp>
+        <p:nvSpPr>
+          <p:cNvPr id="11" name="TextBox 10"/>
+          <p:cNvSpPr txBox="1"/>
+          <p:nvPr/>
+        </p:nvSpPr>
+        <p:spPr>
+          <a:xfrm>
+            <a:off x="731520" y="2578608"/>
+            <a:ext cx="5135727" cy="2834640"/>
+          </a:xfrm>
+          <a:prstGeom prst="rect">
+            <a:avLst/>
+          </a:prstGeom>
+          <a:noFill/>
+        </p:spPr>
+        <p:txBody>
+          <a:bodyPr wrap="square" anchor="t">
+            <a:spAutoFit/>
+          </a:bodyPr>
+          <a:lstStyle/>
+          <a:p>
+            <a:pPr algn="l"/>
+            <a:r>
+              <a:rPr sz="2000" b="0">
+                <a:solidFill>
+                  <a:srgbClr val="4ADFCB"/>
+                </a:solidFill>
+                <a:latin typeface="Consolas"/>
+              </a:rPr>
+              <a:t>{{ANTES_CODIGO}}</a:t>
+            </a:r>
+          </a:p>
+        </p:txBody>
+      </p:sp>
+      <p:sp>
+        <p:nvSpPr>
+          <p:cNvPr id="12" name="TextBox 11"/>
+          <p:cNvSpPr txBox="1"/>
+          <p:nvPr/>
+        </p:nvSpPr>
+        <p:spPr>
+          <a:xfrm>
+            <a:off x="6233007" y="2011680"/>
+            <a:ext cx="5410047" cy="365760"/>
+          </a:xfrm>
+          <a:prstGeom prst="rect">
+            <a:avLst/>
+          </a:prstGeom>
+          <a:noFill/>
+        </p:spPr>
+        <p:txBody>
+          <a:bodyPr wrap="square" anchor="t">
+            <a:spAutoFit/>
+          </a:bodyPr>
+          <a:lstStyle/>
+          <a:p>
+            <a:pPr algn="l"/>
+            <a:r>
+              <a:rPr sz="1800" b="1">
+                <a:solidFill>
+                  <a:srgbClr val="02C39A"/>
+                </a:solidFill>
+                <a:latin typeface="Calibri"/>
+              </a:rPr>
+              <a:t>{{DESPUES_LABEL}}</a:t>
+            </a:r>
+          </a:p>
+        </p:txBody>
+      </p:sp>
+      <p:sp>
+        <p:nvSpPr>
+          <p:cNvPr id="13" name="Rectangle 12"/>
+          <p:cNvSpPr/>
+          <p:nvPr/>
+        </p:nvSpPr>
+        <p:spPr>
+          <a:xfrm>
+            <a:off x="6233007" y="2423160"/>
+            <a:ext cx="5410047" cy="3108960"/>
+          </a:xfrm>
+          <a:prstGeom prst="rect">
+            <a:avLst/>
+          </a:prstGeom>
+          <a:solidFill>
+            <a:srgbClr val="0D1117"/>
+          </a:solidFill>
+          <a:ln>
+            <a:noFill/>
+          </a:ln>
+          <a:effectLst/>
+        </p:spPr>
+        <p:style>
+          <a:lnRef idx="1">
+            <a:schemeClr val="accent1"/>
+          </a:lnRef>
+          <a:fillRef idx="3">
+            <a:schemeClr val="accent1"/>
+          </a:fillRef>
+          <a:effectRef idx="2">
+            <a:schemeClr val="accent1"/>
+          </a:effectRef>
+          <a:fontRef idx="minor">
+            <a:schemeClr val="lt1"/>
+          </a:fontRef>
+        </p:style>
+        <p:txBody>
+          <a:bodyPr rtlCol="0" anchor="ctr"/>
+          <a:lstStyle/>
+          <a:p>
+            <a:pPr algn="ctr"/>
+          </a:p>
+        </p:txBody>
+      </p:sp>
+      <p:sp>
+        <p:nvSpPr>
+          <p:cNvPr id="14" name="Rectangle 13"/>
+          <p:cNvSpPr/>
+          <p:nvPr/>
+        </p:nvSpPr>
+        <p:spPr>
+          <a:xfrm>
+            <a:off x="6233007" y="2423160"/>
+            <a:ext cx="5410047" cy="73152"/>
+          </a:xfrm>
+          <a:prstGeom prst="rect">
+            <a:avLst/>
+          </a:prstGeom>
+          <a:solidFill>
+            <a:srgbClr val="02C39A"/>
+          </a:solidFill>
+          <a:ln>
+            <a:noFill/>
+          </a:ln>
+          <a:effectLst/>
+        </p:spPr>
+        <p:style>
+          <a:lnRef idx="1">
+            <a:schemeClr val="accent1"/>
+          </a:lnRef>
+          <a:fillRef idx="3">
+            <a:schemeClr val="accent1"/>
+          </a:fillRef>
+          <a:effectRef idx="2">
+            <a:schemeClr val="accent1"/>
+          </a:effectRef>
+          <a:fontRef idx="minor">
+            <a:schemeClr val="lt1"/>
+          </a:fontRef>
+        </p:style>
+        <p:txBody>
+          <a:bodyPr rtlCol="0" anchor="ctr"/>
+          <a:lstStyle/>
+          <a:p>
+            <a:pPr algn="ctr"/>
+          </a:p>
+        </p:txBody>
+      </p:sp>
+      <p:sp>
+        <p:nvSpPr>
+          <p:cNvPr id="15" name="TextBox 14"/>
+          <p:cNvSpPr txBox="1"/>
+          <p:nvPr/>
+        </p:nvSpPr>
+        <p:spPr>
+          <a:xfrm>
+            <a:off x="6415887" y="2578608"/>
+            <a:ext cx="5135727" cy="2834640"/>
+          </a:xfrm>
+          <a:prstGeom prst="rect">
+            <a:avLst/>
+          </a:prstGeom>
+          <a:noFill/>
+        </p:spPr>
+        <p:txBody>
+          <a:bodyPr wrap="square" anchor="t">
+            <a:spAutoFit/>
+          </a:bodyPr>
+          <a:lstStyle/>
+          <a:p>
+            <a:pPr algn="l"/>
+            <a:r>
+              <a:rPr sz="2000" b="0">
+                <a:solidFill>
+                  <a:srgbClr val="4ADFCB"/>
+                </a:solidFill>
+                <a:latin typeface="Consolas"/>
+              </a:rPr>
+              <a:t>{{DESPUES_CODIGO}}</a:t>
+            </a:r>
+          </a:p>
+        </p:txBody>
+      </p:sp>
+      <p:sp>
+        <p:nvSpPr>
+          <p:cNvPr id="16" name="Rectangle 15"/>
+          <p:cNvSpPr/>
+          <p:nvPr/>
+        </p:nvSpPr>
+        <p:spPr>
+          <a:xfrm>
+            <a:off x="548640" y="5760720"/>
+            <a:ext cx="11094415" cy="868679"/>
+          </a:xfrm>
+          <a:prstGeom prst="rect">
+            <a:avLst/>
+          </a:prstGeom>
+          <a:solidFill>
+            <a:srgbClr val="16213E"/>
+          </a:solidFill>
+          <a:ln>
+            <a:noFill/>
+          </a:ln>
+          <a:effectLst/>
+        </p:spPr>
+        <p:style>
+          <a:lnRef idx="1">
+            <a:schemeClr val="accent1"/>
+          </a:lnRef>
+          <a:fillRef idx="3">
+            <a:schemeClr val="accent1"/>
+          </a:fillRef>
+          <a:effectRef idx="2">
+            <a:schemeClr val="accent1"/>
+          </a:effectRef>
+          <a:fontRef idx="minor">
+            <a:schemeClr val="lt1"/>
+          </a:fontRef>
+        </p:style>
+        <p:txBody>
+          <a:bodyPr rtlCol="0" anchor="ctr"/>
+          <a:lstStyle/>
+          <a:p>
+            <a:pPr algn="ctr"/>
+          </a:p>
+        </p:txBody>
+      </p:sp>
+      <p:sp>
+        <p:nvSpPr>
+          <p:cNvPr id="17" name="Rectangle 16"/>
+          <p:cNvSpPr/>
+          <p:nvPr/>
+        </p:nvSpPr>
+        <p:spPr>
+          <a:xfrm>
+            <a:off x="548640" y="5760720"/>
+            <a:ext cx="73152" cy="868679"/>
+          </a:xfrm>
+          <a:prstGeom prst="rect">
+            <a:avLst/>
+          </a:prstGeom>
+          <a:solidFill>
+            <a:srgbClr val="F5A623"/>
+          </a:solidFill>
+          <a:ln>
+            <a:noFill/>
+          </a:ln>
+          <a:effectLst/>
+        </p:spPr>
+        <p:style>
+          <a:lnRef idx="1">
+            <a:schemeClr val="accent1"/>
+          </a:lnRef>
+          <a:fillRef idx="3">
+            <a:schemeClr val="accent1"/>
+          </a:fillRef>
+          <a:effectRef idx="2">
+            <a:schemeClr val="accent1"/>
+          </a:effectRef>
+          <a:fontRef idx="minor">
+            <a:schemeClr val="lt1"/>
+          </a:fontRef>
+        </p:style>
+        <p:txBody>
+          <a:bodyPr rtlCol="0" anchor="ctr"/>
+          <a:lstStyle/>
+          <a:p>
+            <a:pPr algn="ctr"/>
+          </a:p>
+        </p:txBody>
+      </p:sp>
+      <p:sp>
+        <p:nvSpPr>
+          <p:cNvPr id="18" name="TextBox 17"/>
+          <p:cNvSpPr txBox="1"/>
+          <p:nvPr/>
+        </p:nvSpPr>
+        <p:spPr>
+          <a:xfrm>
+            <a:off x="777240" y="5806440"/>
+            <a:ext cx="10728655" cy="777239"/>
+          </a:xfrm>
+          <a:prstGeom prst="rect">
+            <a:avLst/>
+          </a:prstGeom>
+          <a:noFill/>
+        </p:spPr>
+        <p:txBody>
+          <a:bodyPr wrap="square" anchor="ctr">
+            <a:spAutoFit/>
+          </a:bodyPr>
+          <a:lstStyle/>
+          <a:p>
+            <a:pPr algn="l"/>
+            <a:r>
+              <a:rPr sz="2200" b="0">
+                <a:solidFill>
+                  <a:srgbClr val="FFFFFF"/>
+                </a:solidFill>
+                <a:latin typeface="Calibri"/>
+              </a:rPr>
+              <a:t>💡  {{TAKEAWAY}}</a:t>
+            </a:r>
+          </a:p>
+        </p:txBody>
+      </p:sp>
+    </p:spTree>
+  </p:cSld>
+  <p:clrMapOvr>
+    <a:masterClrMapping/>
+  </p:clrMapOvr>
+</p:sld>
+</file>
+
+<file path=ppt/slides/slide14.xml><?xml version="1.0" encoding="utf-8"?>
+<p:sld xmlns:a="http://schemas.openxmlformats.org/drawingml/2006/main" xmlns:p="http://schemas.openxmlformats.org/presentationml/2006/main" xmlns:r="http://schemas.openxmlformats.org/officeDocument/2006/relationships">
+  <p:cSld>
+    <p:spTree>
+      <p:nvGrpSpPr>
+        <p:cNvPr id="1" name=""/>
+        <p:cNvGrpSpPr/>
+        <p:nvPr/>
+      </p:nvGrpSpPr>
+      <p:grpSpPr/>
+      <p:sp>
+        <p:nvSpPr>
+          <p:cNvPr id="2" name="Rectangle 1"/>
+          <p:cNvSpPr/>
+          <p:nvPr/>
+        </p:nvSpPr>
+        <p:spPr>
+          <a:xfrm>
+            <a:off x="0" y="0"/>
+            <a:ext cx="12191695" cy="6858000"/>
+          </a:xfrm>
+          <a:prstGeom prst="rect">
+            <a:avLst/>
+          </a:prstGeom>
+          <a:solidFill>
+            <a:srgbClr val="1A1A2E"/>
+          </a:solidFill>
+          <a:ln>
+            <a:noFill/>
+          </a:ln>
+          <a:effectLst/>
+        </p:spPr>
+        <p:style>
+          <a:lnRef idx="1">
+            <a:schemeClr val="accent1"/>
+          </a:lnRef>
+          <a:fillRef idx="3">
+            <a:schemeClr val="accent1"/>
+          </a:fillRef>
+          <a:effectRef idx="2">
+            <a:schemeClr val="accent1"/>
+          </a:effectRef>
+          <a:fontRef idx="minor">
+            <a:schemeClr val="lt1"/>
+          </a:fontRef>
+        </p:style>
+        <p:txBody>
+          <a:bodyPr rtlCol="0" anchor="ctr"/>
+          <a:lstStyle/>
+          <a:p>
+            <a:pPr algn="ctr"/>
+          </a:p>
+        </p:txBody>
+      </p:sp>
+      <p:sp>
+        <p:nvSpPr>
+          <p:cNvPr id="3" name="Rectangle 2"/>
+          <p:cNvSpPr/>
+          <p:nvPr/>
+        </p:nvSpPr>
+        <p:spPr>
+          <a:xfrm>
+            <a:off x="0" y="0"/>
+            <a:ext cx="12191695" cy="502920"/>
+          </a:xfrm>
+          <a:prstGeom prst="rect">
+            <a:avLst/>
+          </a:prstGeom>
+          <a:solidFill>
+            <a:srgbClr val="0F162A"/>
+          </a:solidFill>
+          <a:ln>
+            <a:noFill/>
+          </a:ln>
+          <a:effectLst/>
+        </p:spPr>
+        <p:style>
+          <a:lnRef idx="1">
+            <a:schemeClr val="accent1"/>
+          </a:lnRef>
+          <a:fillRef idx="3">
+            <a:schemeClr val="accent1"/>
+          </a:fillRef>
+          <a:effectRef idx="2">
+            <a:schemeClr val="accent1"/>
+          </a:effectRef>
+          <a:fontRef idx="minor">
+            <a:schemeClr val="lt1"/>
+          </a:fontRef>
+        </p:style>
+        <p:txBody>
+          <a:bodyPr rtlCol="0" anchor="ctr"/>
+          <a:lstStyle/>
+          <a:p>
+            <a:pPr algn="ctr"/>
+          </a:p>
+        </p:txBody>
+      </p:sp>
+      <p:sp>
+        <p:nvSpPr>
+          <p:cNvPr id="4" name="TextBox 3"/>
+          <p:cNvSpPr txBox="1"/>
+          <p:nvPr/>
+        </p:nvSpPr>
+        <p:spPr>
+          <a:xfrm>
+            <a:off x="411479" y="118872"/>
+            <a:ext cx="5486400" cy="320040"/>
+          </a:xfrm>
+          <a:prstGeom prst="rect">
+            <a:avLst/>
+          </a:prstGeom>
+          <a:noFill/>
+        </p:spPr>
+        <p:txBody>
+          <a:bodyPr wrap="square" anchor="ctr">
+            <a:spAutoFit/>
+          </a:bodyPr>
+          <a:lstStyle/>
+          <a:p>
+            <a:pPr algn="l"/>
+            <a:r>
+              <a:rPr sz="1200" b="0">
+                <a:solidFill>
+                  <a:srgbClr val="94A3B8"/>
+                </a:solidFill>
+                <a:latin typeface="Consolas"/>
+              </a:rPr>
+              <a:t>🐍 Python · Clase {{NUMERO_CLASE}}</a:t>
+            </a:r>
+          </a:p>
+        </p:txBody>
+      </p:sp>
+      <p:sp>
+        <p:nvSpPr>
+          <p:cNvPr id="5" name="TextBox 4"/>
+          <p:cNvSpPr txBox="1"/>
+          <p:nvPr/>
+        </p:nvSpPr>
+        <p:spPr>
+          <a:xfrm>
+            <a:off x="8534095" y="118872"/>
+            <a:ext cx="3200400" cy="320040"/>
+          </a:xfrm>
+          <a:prstGeom prst="rect">
+            <a:avLst/>
+          </a:prstGeom>
+          <a:noFill/>
+        </p:spPr>
+        <p:txBody>
+          <a:bodyPr wrap="square" anchor="ctr">
+            <a:spAutoFit/>
+          </a:bodyPr>
+          <a:lstStyle/>
+          <a:p>
+            <a:pPr algn="r"/>
+            <a:r>
+              <a:rPr sz="1200" b="1">
+                <a:solidFill>
+                  <a:srgbClr val="0F9B8E"/>
+                </a:solidFill>
+                <a:latin typeface="Consolas"/>
+              </a:rPr>
+              <a:t>{{SECCION}}</a:t>
+            </a:r>
+          </a:p>
+        </p:txBody>
+      </p:sp>
+      <p:sp>
+        <p:nvSpPr>
+          <p:cNvPr id="6" name="TextBox 5"/>
+          <p:cNvSpPr txBox="1"/>
+          <p:nvPr/>
+        </p:nvSpPr>
+        <p:spPr>
+          <a:xfrm>
+            <a:off x="548640" y="1097280"/>
+            <a:ext cx="1828800" cy="1371600"/>
+          </a:xfrm>
+          <a:prstGeom prst="rect">
+            <a:avLst/>
+          </a:prstGeom>
+          <a:noFill/>
+        </p:spPr>
+        <p:txBody>
+          <a:bodyPr wrap="square" anchor="t">
+            <a:spAutoFit/>
+          </a:bodyPr>
+          <a:lstStyle/>
+          <a:p>
+            <a:pPr algn="l"/>
+            <a:r>
+              <a:rPr sz="12000" b="1">
+                <a:solidFill>
+                  <a:srgbClr val="0F9B8E"/>
+                </a:solidFill>
+                <a:latin typeface="Calibri"/>
+              </a:rPr>
+              <a:t>“</a:t>
+            </a:r>
+          </a:p>
+        </p:txBody>
+      </p:sp>
+      <p:sp>
+        <p:nvSpPr>
+          <p:cNvPr id="7" name="TextBox 6"/>
+          <p:cNvSpPr txBox="1"/>
+          <p:nvPr/>
+        </p:nvSpPr>
+        <p:spPr>
+          <a:xfrm>
+            <a:off x="1005840" y="2194560"/>
+            <a:ext cx="10180015" cy="2926080"/>
+          </a:xfrm>
+          <a:prstGeom prst="rect">
+            <a:avLst/>
+          </a:prstGeom>
+          <a:noFill/>
+        </p:spPr>
+        <p:txBody>
+          <a:bodyPr wrap="square" anchor="ctr">
+            <a:normAutofit/>
+          </a:bodyPr>
+          <a:lstStyle/>
+          <a:p>
+            <a:pPr algn="l"/>
+            <a:r>
+              <a:rPr sz="4000" b="1">
+                <a:solidFill>
+                  <a:srgbClr val="FFFFFF"/>
+                </a:solidFill>
+                <a:latin typeface="Calibri"/>
+              </a:rPr>
+              <a:t>{{FRASE}}</a:t>
+            </a:r>
+          </a:p>
+        </p:txBody>
+      </p:sp>
+      <p:sp>
+        <p:nvSpPr>
+          <p:cNvPr id="8" name="TextBox 7"/>
+          <p:cNvSpPr txBox="1"/>
+          <p:nvPr/>
+        </p:nvSpPr>
+        <p:spPr>
+          <a:xfrm>
+            <a:off x="1005840" y="5303520"/>
+            <a:ext cx="10180015" cy="457200"/>
+          </a:xfrm>
+          <a:prstGeom prst="rect">
+            <a:avLst/>
+          </a:prstGeom>
+          <a:noFill/>
+        </p:spPr>
+        <p:txBody>
+          <a:bodyPr wrap="square" anchor="t">
+            <a:spAutoFit/>
+          </a:bodyPr>
+          <a:lstStyle/>
+          <a:p>
+            <a:pPr algn="l"/>
+            <a:r>
+              <a:rPr sz="1800" b="1">
+                <a:solidFill>
+                  <a:srgbClr val="02C39A"/>
+                </a:solidFill>
+                <a:latin typeface="Calibri"/>
+              </a:rPr>
+              <a:t>— {{ATRIBUCION}}</a:t>
             </a:r>
           </a:p>
         </p:txBody>

</xml_diff>